<commit_message>
build_novel_ppt.py를 ppt_module 기반으로 재작성, 가이드 재생성
텍스트박스/사각형 생성을 ppt_module에 위임해 "\n" 줄바꿈 누락과
칸 밖 범람 버그를 수정. 헤더(캡션/제목/부제)와 표지 제목을 실측
높이로 순차 배치해 두 줄 제목·헤더가 바로 아래 줄과 겹치던 문제를
고쳤고, 저장 전 ppt_module.validate로 겹침/경계 이탈이 없음을 확인.
소설쓰기_가이드.pptx를 이 수정 내용으로 재생성.
</commit_message>
<xml_diff>
--- a/소설쓰기_가이드.pptx
+++ b/소설쓰기_가이드.pptx
@@ -3270,7 +3270,7 @@
         <p:spPr>
           <a:xfrm>
             <a:off x="777240" y="1536192"/>
-            <a:ext cx="5669280" cy="1691640"/>
+            <a:ext cx="5669280" cy="1860279"/>
           </a:xfrm>
           <a:prstGeom prst="rect">
             <a:avLst/>
@@ -3296,8 +3296,18 @@
                 <a:latin typeface="Noto Sans CJK KR"/>
                 <a:ea typeface="Noto Sans CJK KR"/>
               </a:rPr>
-              <a:t>매혹적인
-소설 쓰기의 기술</a:t>
+              <a:t>매혹적인</a:t>
+            </a:r>
+            <a:br/>
+            <a:r>
+              <a:rPr sz="4200" b="1" i="0">
+                <a:solidFill>
+                  <a:srgbClr val="F2EFE9"/>
+                </a:solidFill>
+                <a:latin typeface="Noto Sans CJK KR"/>
+                <a:ea typeface="Noto Sans CJK KR"/>
+              </a:rPr>
+              <a:t>소설 쓰기의 기술</a:t>
             </a:r>
           </a:p>
         </p:txBody>
@@ -3310,7 +3320,7 @@
         </p:nvSpPr>
         <p:spPr>
           <a:xfrm>
-            <a:off x="777240" y="3337560"/>
+            <a:off x="777240" y="3487911"/>
             <a:ext cx="1463040" cy="64008"/>
           </a:xfrm>
           <a:prstGeom prst="rect">
@@ -3354,8 +3364,8 @@
         </p:nvSpPr>
         <p:spPr>
           <a:xfrm>
-            <a:off x="777240" y="3584448"/>
-            <a:ext cx="5486400" cy="868680"/>
+            <a:off x="777240" y="3643359"/>
+            <a:ext cx="5486400" cy="804062"/>
           </a:xfrm>
           <a:prstGeom prst="rect">
             <a:avLst/>
@@ -3381,8 +3391,18 @@
                 <a:latin typeface="Noto Sans CJK KR"/>
                 <a:ea typeface="Noto Sans CJK KR"/>
               </a:rPr>
-              <a:t>아이디어의 첫 불꽃부터 마지막 문장의 퇴고까지,
-독자의 밤을 빼앗는 서사 설계의 10가지 핵심 원칙</a:t>
+              <a:t>아이디어의 첫 불꽃부터 마지막 문장의 퇴고까지,</a:t>
+            </a:r>
+            <a:br/>
+            <a:r>
+              <a:rPr sz="1500" b="0" i="0">
+                <a:solidFill>
+                  <a:srgbClr val="B2BAC6"/>
+                </a:solidFill>
+                <a:latin typeface="Noto Sans CJK KR"/>
+                <a:ea typeface="Noto Sans CJK KR"/>
+              </a:rPr>
+              <a:t>독자의 밤을 빼앗는 서사 설계의 10가지 핵심 원칙</a:t>
             </a:r>
           </a:p>
         </p:txBody>
@@ -3547,7 +3567,7 @@
               </a:lnSpc>
             </a:pPr>
             <a:r>
-              <a:rPr sz="1450" b="1" i="0">
+              <a:rPr sz="1350" b="1" i="0">
                 <a:solidFill>
                   <a:srgbClr val="F2EFE9"/>
                 </a:solidFill>
@@ -3759,7 +3779,7 @@
               </a:lnSpc>
             </a:pPr>
             <a:r>
-              <a:rPr sz="1450" b="1" i="0">
+              <a:rPr sz="1350" b="1" i="0">
                 <a:solidFill>
                   <a:srgbClr val="F2EFE9"/>
                 </a:solidFill>
@@ -3971,7 +3991,7 @@
               </a:lnSpc>
             </a:pPr>
             <a:r>
-              <a:rPr sz="1450" b="1" i="0">
+              <a:rPr sz="1350" b="1" i="0">
                 <a:solidFill>
                   <a:srgbClr val="F2EFE9"/>
                 </a:solidFill>
@@ -4183,7 +4203,7 @@
               </a:lnSpc>
             </a:pPr>
             <a:r>
-              <a:rPr sz="1450" b="1" i="0">
+              <a:rPr sz="1350" b="1" i="0">
                 <a:solidFill>
                   <a:srgbClr val="F2EFE9"/>
                 </a:solidFill>
@@ -4263,14 +4283,134 @@
       <p:grpSpPr/>
       <p:sp>
         <p:nvSpPr>
-          <p:cNvPr id="2" name="Rectangle 1"/>
+          <p:cNvPr id="2" name="TextBox 1"/>
+          <p:cNvSpPr txBox="1"/>
+          <p:nvPr/>
+        </p:nvSpPr>
+        <p:spPr>
+          <a:xfrm>
+            <a:off x="768096" y="329184"/>
+            <a:ext cx="10789920" cy="219760"/>
+          </a:xfrm>
+          <a:prstGeom prst="rect">
+            <a:avLst/>
+          </a:prstGeom>
+          <a:noFill/>
+        </p:spPr>
+        <p:txBody>
+          <a:bodyPr wrap="square" anchor="t" lIns="18288" rIns="18288" tIns="12801" bIns="12801">
+            <a:spAutoFit/>
+          </a:bodyPr>
+          <a:lstStyle/>
+          <a:p>
+            <a:pPr algn="l">
+              <a:lnSpc>
+                <a:spcPct val="125000"/>
+              </a:lnSpc>
+            </a:pPr>
+            <a:r>
+              <a:rPr sz="800" b="1" i="0">
+                <a:solidFill>
+                  <a:srgbClr val="D19830"/>
+                </a:solidFill>
+                <a:latin typeface="Noto Sans CJK KR"/>
+                <a:ea typeface="Noto Sans CJK KR"/>
+              </a:rPr>
+              <a:t>09  |  THE WRITER'S HABIT &amp; NEXT STEPS</a:t>
+            </a:r>
+          </a:p>
+        </p:txBody>
+      </p:sp>
+      <p:sp>
+        <p:nvSpPr>
+          <p:cNvPr id="3" name="TextBox 2"/>
+          <p:cNvSpPr txBox="1"/>
+          <p:nvPr/>
+        </p:nvSpPr>
+        <p:spPr>
+          <a:xfrm>
+            <a:off x="768096" y="631240"/>
+            <a:ext cx="10789920" cy="423164"/>
+          </a:xfrm>
+          <a:prstGeom prst="rect">
+            <a:avLst/>
+          </a:prstGeom>
+          <a:noFill/>
+        </p:spPr>
+        <p:txBody>
+          <a:bodyPr wrap="square" anchor="t" lIns="18288" rIns="18288" tIns="12801" bIns="12801">
+            <a:spAutoFit/>
+          </a:bodyPr>
+          <a:lstStyle/>
+          <a:p>
+            <a:pPr algn="l">
+              <a:lnSpc>
+                <a:spcPct val="125000"/>
+              </a:lnSpc>
+            </a:pPr>
+            <a:r>
+              <a:rPr sz="1700" b="1" i="0">
+                <a:solidFill>
+                  <a:srgbClr val="F2EFE9"/>
+                </a:solidFill>
+                <a:latin typeface="Noto Sans CJK KR"/>
+                <a:ea typeface="Noto Sans CJK KR"/>
+              </a:rPr>
+              <a:t>완벽한 첫 문장을 기다리지 말고, 지금 당장 첫 장면을 시작하라</a:t>
+            </a:r>
+          </a:p>
+        </p:txBody>
+      </p:sp>
+      <p:sp>
+        <p:nvSpPr>
+          <p:cNvPr id="4" name="TextBox 3"/>
+          <p:cNvSpPr txBox="1"/>
+          <p:nvPr/>
+        </p:nvSpPr>
+        <p:spPr>
+          <a:xfrm>
+            <a:off x="768096" y="1136700"/>
+            <a:ext cx="10789920" cy="247497"/>
+          </a:xfrm>
+          <a:prstGeom prst="rect">
+            <a:avLst/>
+          </a:prstGeom>
+          <a:noFill/>
+        </p:spPr>
+        <p:txBody>
+          <a:bodyPr wrap="square" anchor="t" lIns="18288" rIns="18288" tIns="12801" bIns="12801">
+            <a:spAutoFit/>
+          </a:bodyPr>
+          <a:lstStyle/>
+          <a:p>
+            <a:pPr algn="l">
+              <a:lnSpc>
+                <a:spcPct val="125000"/>
+              </a:lnSpc>
+            </a:pPr>
+            <a:r>
+              <a:rPr sz="950" b="0" i="0">
+                <a:solidFill>
+                  <a:srgbClr val="B2BAC6"/>
+                </a:solidFill>
+                <a:latin typeface="Noto Sans CJK KR"/>
+                <a:ea typeface="Noto Sans CJK KR"/>
+              </a:rPr>
+              <a:t>재능보다 강력한 것은 매일 책상 앞에 앉는 루틴과 끝까지 마침표를 찍어본 완주의 근육이다</a:t>
+            </a:r>
+          </a:p>
+        </p:txBody>
+      </p:sp>
+      <p:sp>
+        <p:nvSpPr>
+          <p:cNvPr id="5" name="Rectangle 4"/>
           <p:cNvSpPr/>
           <p:nvPr/>
         </p:nvSpPr>
         <p:spPr>
           <a:xfrm>
             <a:off x="594360" y="384048"/>
-            <a:ext cx="73152" cy="713232"/>
+            <a:ext cx="73152" cy="917854"/>
           </a:xfrm>
           <a:prstGeom prst="rect">
             <a:avLst/>
@@ -4307,133 +4447,13 @@
       </p:sp>
       <p:sp>
         <p:nvSpPr>
-          <p:cNvPr id="3" name="TextBox 2"/>
-          <p:cNvSpPr txBox="1"/>
-          <p:nvPr/>
-        </p:nvSpPr>
-        <p:spPr>
-          <a:xfrm>
-            <a:off x="768096" y="329184"/>
-            <a:ext cx="8229600" cy="256032"/>
-          </a:xfrm>
-          <a:prstGeom prst="rect">
-            <a:avLst/>
-          </a:prstGeom>
-          <a:noFill/>
-        </p:spPr>
-        <p:txBody>
-          <a:bodyPr wrap="square" anchor="t" lIns="18288" rIns="18288" tIns="12801" bIns="12801">
-            <a:spAutoFit/>
-          </a:bodyPr>
-          <a:lstStyle/>
-          <a:p>
-            <a:pPr algn="l">
-              <a:lnSpc>
-                <a:spcPct val="125000"/>
-              </a:lnSpc>
-            </a:pPr>
-            <a:r>
-              <a:rPr sz="1050" b="1" i="0">
-                <a:solidFill>
-                  <a:srgbClr val="D19830"/>
-                </a:solidFill>
-                <a:latin typeface="Noto Sans CJK KR"/>
-                <a:ea typeface="Noto Sans CJK KR"/>
-              </a:rPr>
-              <a:t>09  |  THE WRITER'S HABIT &amp; NEXT STEPS</a:t>
-            </a:r>
-          </a:p>
-        </p:txBody>
-      </p:sp>
-      <p:sp>
-        <p:nvSpPr>
-          <p:cNvPr id="4" name="TextBox 3"/>
-          <p:cNvSpPr txBox="1"/>
-          <p:nvPr/>
-        </p:nvSpPr>
-        <p:spPr>
-          <a:xfrm>
-            <a:off x="768096" y="548640"/>
-            <a:ext cx="10789920" cy="402336"/>
-          </a:xfrm>
-          <a:prstGeom prst="rect">
-            <a:avLst/>
-          </a:prstGeom>
-          <a:noFill/>
-        </p:spPr>
-        <p:txBody>
-          <a:bodyPr wrap="square" anchor="t" lIns="18288" rIns="18288" tIns="12801" bIns="12801">
-            <a:spAutoFit/>
-          </a:bodyPr>
-          <a:lstStyle/>
-          <a:p>
-            <a:pPr algn="l">
-              <a:lnSpc>
-                <a:spcPct val="125000"/>
-              </a:lnSpc>
-            </a:pPr>
-            <a:r>
-              <a:rPr sz="2150" b="1" i="0">
-                <a:solidFill>
-                  <a:srgbClr val="F2EFE9"/>
-                </a:solidFill>
-                <a:latin typeface="Noto Sans CJK KR"/>
-                <a:ea typeface="Noto Sans CJK KR"/>
-              </a:rPr>
-              <a:t>완벽한 첫 문장을 기다리지 말고, 지금 당장 첫 장면을 시작하라</a:t>
-            </a:r>
-          </a:p>
-        </p:txBody>
-      </p:sp>
-      <p:sp>
-        <p:nvSpPr>
-          <p:cNvPr id="5" name="TextBox 4"/>
-          <p:cNvSpPr txBox="1"/>
-          <p:nvPr/>
-        </p:nvSpPr>
-        <p:spPr>
-          <a:xfrm>
-            <a:off x="768096" y="923544"/>
-            <a:ext cx="10789920" cy="292608"/>
-          </a:xfrm>
-          <a:prstGeom prst="rect">
-            <a:avLst/>
-          </a:prstGeom>
-          <a:noFill/>
-        </p:spPr>
-        <p:txBody>
-          <a:bodyPr wrap="square" anchor="t" lIns="18288" rIns="18288" tIns="12801" bIns="12801">
-            <a:spAutoFit/>
-          </a:bodyPr>
-          <a:lstStyle/>
-          <a:p>
-            <a:pPr algn="l">
-              <a:lnSpc>
-                <a:spcPct val="125000"/>
-              </a:lnSpc>
-            </a:pPr>
-            <a:r>
-              <a:rPr sz="1200" b="0" i="0">
-                <a:solidFill>
-                  <a:srgbClr val="B2BAC6"/>
-                </a:solidFill>
-                <a:latin typeface="Noto Sans CJK KR"/>
-                <a:ea typeface="Noto Sans CJK KR"/>
-              </a:rPr>
-              <a:t>재능보다 강력한 것은 매일 책상 앞에 앉는 루틴과 끝까지 마침표를 찍어본 완주의 근육이다</a:t>
-            </a:r>
-          </a:p>
-        </p:txBody>
-      </p:sp>
-      <p:sp>
-        <p:nvSpPr>
           <p:cNvPr id="6" name="Rectangle 5"/>
           <p:cNvSpPr/>
           <p:nvPr/>
         </p:nvSpPr>
         <p:spPr>
           <a:xfrm>
-            <a:off x="594360" y="1261872"/>
+            <a:off x="594360" y="1457350"/>
             <a:ext cx="11000232" cy="13716"/>
           </a:xfrm>
           <a:prstGeom prst="rect">
@@ -4713,7 +4733,7 @@
               </a:lnSpc>
             </a:pPr>
             <a:r>
-              <a:rPr sz="1000" b="1" i="0">
+              <a:rPr sz="950" b="1" i="0">
                 <a:solidFill>
                   <a:srgbClr val="C6532D"/>
                 </a:solidFill>
@@ -4753,7 +4773,7 @@
               </a:lnSpc>
             </a:pPr>
             <a:r>
-              <a:rPr sz="1450" b="1" i="0">
+              <a:rPr sz="1350" b="1" i="0">
                 <a:solidFill>
                   <a:srgbClr val="F2EFE9"/>
                 </a:solidFill>
@@ -4888,9 +4908,29 @@
                 <a:latin typeface="Noto Sans CJK KR"/>
                 <a:ea typeface="Noto Sans CJK KR"/>
               </a:rPr>
-              <a:t>• 매일 같은 시간, 같은 장소에서 정해진 분량(예: 하루 1,000자~2,000자 또는 45분)을 채우는 시스템 구축
-• 다음 날 글쓰기가 막막하지 않도록, 오늘 가장 잘 써지는 장면의 문장 중간에서 멈추는 ‘헤밍웨이 기법’ 활용
-• 하루 1,500자씩 60일이면 단편 3편 또는 경장편 1권 분량(원고지 450매)이 완성된다</a:t>
+              <a:t>• 매일 같은 시간, 같은 장소에서 정해진 분량(예: 하루 1,000자~2,000자 또는 45분)을 채우는 시스템 구축</a:t>
+            </a:r>
+            <a:br/>
+            <a:r>
+              <a:rPr sz="1030" b="0" i="0">
+                <a:solidFill>
+                  <a:srgbClr val="B2BAC6"/>
+                </a:solidFill>
+                <a:latin typeface="Noto Sans CJK KR"/>
+                <a:ea typeface="Noto Sans CJK KR"/>
+              </a:rPr>
+              <a:t>• 다음 날 글쓰기가 막막하지 않도록, 오늘 가장 잘 써지는 장면의 문장 중간에서 멈추는 ‘헤밍웨이 기법’ 활용</a:t>
+            </a:r>
+            <a:br/>
+            <a:r>
+              <a:rPr sz="1030" b="0" i="0">
+                <a:solidFill>
+                  <a:srgbClr val="B2BAC6"/>
+                </a:solidFill>
+                <a:latin typeface="Noto Sans CJK KR"/>
+                <a:ea typeface="Noto Sans CJK KR"/>
+              </a:rPr>
+              <a:t>• 하루 1,500자씩 60일이면 단편 3편 또는 경장편 1권 분량(원고지 450매)이 완성된다</a:t>
             </a:r>
           </a:p>
         </p:txBody>
@@ -5015,7 +5055,7 @@
               </a:lnSpc>
             </a:pPr>
             <a:r>
-              <a:rPr sz="1000" b="1" i="0">
+              <a:rPr sz="950" b="1" i="0">
                 <a:solidFill>
                   <a:srgbClr val="D19830"/>
                 </a:solidFill>
@@ -5055,7 +5095,7 @@
               </a:lnSpc>
             </a:pPr>
             <a:r>
-              <a:rPr sz="1450" b="1" i="0">
+              <a:rPr sz="1350" b="1" i="0">
                 <a:solidFill>
                   <a:srgbClr val="F2EFE9"/>
                 </a:solidFill>
@@ -5190,9 +5230,29 @@
                 <a:latin typeface="Noto Sans CJK KR"/>
                 <a:ea typeface="Noto Sans CJK KR"/>
               </a:rPr>
-              <a:t>• 지하철에서 들은 기묘한 대화 한 줄, 독특한 직업군의 은어, 계절별 빛과 냄새를 메모장에 즉시 기록
-• 마음에 드는 소설을 읽을 때는 독자로서 한 번, 작가로서 ‘어떻게 이 감정을 설계했는가’ 분석하며 한 번 더 필사·해부
-• 막힐 때마다 꺼내 쓸 수 있는 나만의 ‘인물·장면·어휘 창고’를 상시 비축</a:t>
+              <a:t>• 지하철에서 들은 기묘한 대화 한 줄, 독특한 직업군의 은어, 계절별 빛과 냄새를 메모장에 즉시 기록</a:t>
+            </a:r>
+            <a:br/>
+            <a:r>
+              <a:rPr sz="1030" b="0" i="0">
+                <a:solidFill>
+                  <a:srgbClr val="B2BAC6"/>
+                </a:solidFill>
+                <a:latin typeface="Noto Sans CJK KR"/>
+                <a:ea typeface="Noto Sans CJK KR"/>
+              </a:rPr>
+              <a:t>• 마음에 드는 소설을 읽을 때는 독자로서 한 번, 작가로서 ‘어떻게 이 감정을 설계했는가’ 분석하며 한 번 더 필사·해부</a:t>
+            </a:r>
+            <a:br/>
+            <a:r>
+              <a:rPr sz="1030" b="0" i="0">
+                <a:solidFill>
+                  <a:srgbClr val="B2BAC6"/>
+                </a:solidFill>
+                <a:latin typeface="Noto Sans CJK KR"/>
+                <a:ea typeface="Noto Sans CJK KR"/>
+              </a:rPr>
+              <a:t>• 막힐 때마다 꺼내 쓸 수 있는 나만의 ‘인물·장면·어휘 창고’를 상시 비축</a:t>
             </a:r>
           </a:p>
         </p:txBody>
@@ -5317,7 +5377,7 @@
               </a:lnSpc>
             </a:pPr>
             <a:r>
-              <a:rPr sz="1000" b="1" i="0">
+              <a:rPr sz="950" b="1" i="0">
                 <a:solidFill>
                   <a:srgbClr val="316B69"/>
                 </a:solidFill>
@@ -5357,7 +5417,7 @@
               </a:lnSpc>
             </a:pPr>
             <a:r>
-              <a:rPr sz="1450" b="1" i="0">
+              <a:rPr sz="1350" b="1" i="0">
                 <a:solidFill>
                   <a:srgbClr val="F2EFE9"/>
                 </a:solidFill>
@@ -5492,9 +5552,29 @@
                 <a:latin typeface="Noto Sans CJK KR"/>
                 <a:ea typeface="Noto Sans CJK KR"/>
               </a:rPr>
-              <a:t>• 처음부터 거대한 10권짜리 세계관에 매몰되기보다, 원고지 70~100매 분량의 단편으로 기승전결 완주 훈련
-• 첫 초고가 마음에 들지 않는 것은 당신의 재능이 부족해서가 아니라 안목이 높기 때문임을 기억
-• 오늘 당장 주인공의 이름과 그가 처한 첫 번째 작은 위기 한 줄을 적는 것으로 시작하라</a:t>
+              <a:t>• 처음부터 거대한 10권짜리 세계관에 매몰되기보다, 원고지 70~100매 분량의 단편으로 기승전결 완주 훈련</a:t>
+            </a:r>
+            <a:br/>
+            <a:r>
+              <a:rPr sz="1030" b="0" i="0">
+                <a:solidFill>
+                  <a:srgbClr val="B2BAC6"/>
+                </a:solidFill>
+                <a:latin typeface="Noto Sans CJK KR"/>
+                <a:ea typeface="Noto Sans CJK KR"/>
+              </a:rPr>
+              <a:t>• 첫 초고가 마음에 들지 않는 것은 당신의 재능이 부족해서가 아니라 안목이 높기 때문임을 기억</a:t>
+            </a:r>
+            <a:br/>
+            <a:r>
+              <a:rPr sz="1030" b="0" i="0">
+                <a:solidFill>
+                  <a:srgbClr val="B2BAC6"/>
+                </a:solidFill>
+                <a:latin typeface="Noto Sans CJK KR"/>
+                <a:ea typeface="Noto Sans CJK KR"/>
+              </a:rPr>
+              <a:t>• 오늘 당장 주인공의 이름과 그가 처한 첫 번째 작은 위기 한 줄을 적는 것으로 시작하라</a:t>
             </a:r>
           </a:p>
         </p:txBody>
@@ -5593,7 +5673,7 @@
         </p:nvSpPr>
         <p:spPr>
           <a:xfrm>
-            <a:off x="777240" y="5907024"/>
+            <a:off x="777240" y="5934456"/>
             <a:ext cx="10634472" cy="292608"/>
           </a:xfrm>
           <a:prstGeom prst="rect">
@@ -5613,7 +5693,7 @@
               </a:lnSpc>
             </a:pPr>
             <a:r>
-              <a:rPr sz="1100" b="0" i="0">
+              <a:rPr sz="900" b="0" i="0">
                 <a:solidFill>
                   <a:srgbClr val="FBF4E4"/>
                 </a:solidFill>
@@ -5653,14 +5733,134 @@
       <p:grpSpPr/>
       <p:sp>
         <p:nvSpPr>
-          <p:cNvPr id="2" name="Rectangle 1"/>
+          <p:cNvPr id="2" name="TextBox 1"/>
+          <p:cNvSpPr txBox="1"/>
+          <p:nvPr/>
+        </p:nvSpPr>
+        <p:spPr>
+          <a:xfrm>
+            <a:off x="768096" y="329184"/>
+            <a:ext cx="10789920" cy="219760"/>
+          </a:xfrm>
+          <a:prstGeom prst="rect">
+            <a:avLst/>
+          </a:prstGeom>
+          <a:noFill/>
+        </p:spPr>
+        <p:txBody>
+          <a:bodyPr wrap="square" anchor="t" lIns="18288" rIns="18288" tIns="12801" bIns="12801">
+            <a:spAutoFit/>
+          </a:bodyPr>
+          <a:lstStyle/>
+          <a:p>
+            <a:pPr algn="l">
+              <a:lnSpc>
+                <a:spcPct val="125000"/>
+              </a:lnSpc>
+            </a:pPr>
+            <a:r>
+              <a:rPr sz="800" b="1" i="0">
+                <a:solidFill>
+                  <a:srgbClr val="C6532D"/>
+                </a:solidFill>
+                <a:latin typeface="Noto Sans CJK KR"/>
+                <a:ea typeface="Noto Sans CJK KR"/>
+              </a:rPr>
+              <a:t>01  |  FICTION ARCHITECTURE</a:t>
+            </a:r>
+          </a:p>
+        </p:txBody>
+      </p:sp>
+      <p:sp>
+        <p:nvSpPr>
+          <p:cNvPr id="3" name="TextBox 2"/>
+          <p:cNvSpPr txBox="1"/>
+          <p:nvPr/>
+        </p:nvSpPr>
+        <p:spPr>
+          <a:xfrm>
+            <a:off x="768096" y="631240"/>
+            <a:ext cx="10789920" cy="423164"/>
+          </a:xfrm>
+          <a:prstGeom prst="rect">
+            <a:avLst/>
+          </a:prstGeom>
+          <a:noFill/>
+        </p:spPr>
+        <p:txBody>
+          <a:bodyPr wrap="square" anchor="t" lIns="18288" rIns="18288" tIns="12801" bIns="12801">
+            <a:spAutoFit/>
+          </a:bodyPr>
+          <a:lstStyle/>
+          <a:p>
+            <a:pPr algn="l">
+              <a:lnSpc>
+                <a:spcPct val="125000"/>
+              </a:lnSpc>
+            </a:pPr>
+            <a:r>
+              <a:rPr sz="1700" b="1" i="0">
+                <a:solidFill>
+                  <a:srgbClr val="1A212E"/>
+                </a:solidFill>
+                <a:latin typeface="Noto Sans CJK KR"/>
+                <a:ea typeface="Noto Sans CJK KR"/>
+              </a:rPr>
+              <a:t>완성도 높은 소설은 소재·인물·플롯·문체의 4대 축으로 작동한다</a:t>
+            </a:r>
+          </a:p>
+        </p:txBody>
+      </p:sp>
+      <p:sp>
+        <p:nvSpPr>
+          <p:cNvPr id="4" name="TextBox 3"/>
+          <p:cNvSpPr txBox="1"/>
+          <p:nvPr/>
+        </p:nvSpPr>
+        <p:spPr>
+          <a:xfrm>
+            <a:off x="768096" y="1136700"/>
+            <a:ext cx="10789920" cy="247497"/>
+          </a:xfrm>
+          <a:prstGeom prst="rect">
+            <a:avLst/>
+          </a:prstGeom>
+          <a:noFill/>
+        </p:spPr>
+        <p:txBody>
+          <a:bodyPr wrap="square" anchor="t" lIns="18288" rIns="18288" tIns="12801" bIns="12801">
+            <a:spAutoFit/>
+          </a:bodyPr>
+          <a:lstStyle/>
+          <a:p>
+            <a:pPr algn="l">
+              <a:lnSpc>
+                <a:spcPct val="125000"/>
+              </a:lnSpc>
+            </a:pPr>
+            <a:r>
+              <a:rPr sz="950" b="0" i="0">
+                <a:solidFill>
+                  <a:srgbClr val="555E6C"/>
+                </a:solidFill>
+                <a:latin typeface="Noto Sans CJK KR"/>
+                <a:ea typeface="Noto Sans CJK KR"/>
+              </a:rPr>
+              <a:t>네 가지 기둥 중 하나라도 무너지면 서사의 설득력이 급격히 약화된다</a:t>
+            </a:r>
+          </a:p>
+        </p:txBody>
+      </p:sp>
+      <p:sp>
+        <p:nvSpPr>
+          <p:cNvPr id="5" name="Rectangle 4"/>
           <p:cNvSpPr/>
           <p:nvPr/>
         </p:nvSpPr>
         <p:spPr>
           <a:xfrm>
             <a:off x="594360" y="384048"/>
-            <a:ext cx="73152" cy="713232"/>
+            <a:ext cx="73152" cy="917854"/>
           </a:xfrm>
           <a:prstGeom prst="rect">
             <a:avLst/>
@@ -5697,133 +5897,13 @@
       </p:sp>
       <p:sp>
         <p:nvSpPr>
-          <p:cNvPr id="3" name="TextBox 2"/>
-          <p:cNvSpPr txBox="1"/>
-          <p:nvPr/>
-        </p:nvSpPr>
-        <p:spPr>
-          <a:xfrm>
-            <a:off x="768096" y="329184"/>
-            <a:ext cx="8229600" cy="256032"/>
-          </a:xfrm>
-          <a:prstGeom prst="rect">
-            <a:avLst/>
-          </a:prstGeom>
-          <a:noFill/>
-        </p:spPr>
-        <p:txBody>
-          <a:bodyPr wrap="square" anchor="t" lIns="18288" rIns="18288" tIns="12801" bIns="12801">
-            <a:spAutoFit/>
-          </a:bodyPr>
-          <a:lstStyle/>
-          <a:p>
-            <a:pPr algn="l">
-              <a:lnSpc>
-                <a:spcPct val="125000"/>
-              </a:lnSpc>
-            </a:pPr>
-            <a:r>
-              <a:rPr sz="1050" b="1" i="0">
-                <a:solidFill>
-                  <a:srgbClr val="C6532D"/>
-                </a:solidFill>
-                <a:latin typeface="Noto Sans CJK KR"/>
-                <a:ea typeface="Noto Sans CJK KR"/>
-              </a:rPr>
-              <a:t>01  |  FICTION ARCHITECTURE</a:t>
-            </a:r>
-          </a:p>
-        </p:txBody>
-      </p:sp>
-      <p:sp>
-        <p:nvSpPr>
-          <p:cNvPr id="4" name="TextBox 3"/>
-          <p:cNvSpPr txBox="1"/>
-          <p:nvPr/>
-        </p:nvSpPr>
-        <p:spPr>
-          <a:xfrm>
-            <a:off x="768096" y="548640"/>
-            <a:ext cx="10789920" cy="402336"/>
-          </a:xfrm>
-          <a:prstGeom prst="rect">
-            <a:avLst/>
-          </a:prstGeom>
-          <a:noFill/>
-        </p:spPr>
-        <p:txBody>
-          <a:bodyPr wrap="square" anchor="t" lIns="18288" rIns="18288" tIns="12801" bIns="12801">
-            <a:spAutoFit/>
-          </a:bodyPr>
-          <a:lstStyle/>
-          <a:p>
-            <a:pPr algn="l">
-              <a:lnSpc>
-                <a:spcPct val="125000"/>
-              </a:lnSpc>
-            </a:pPr>
-            <a:r>
-              <a:rPr sz="2150" b="1" i="0">
-                <a:solidFill>
-                  <a:srgbClr val="1A212E"/>
-                </a:solidFill>
-                <a:latin typeface="Noto Sans CJK KR"/>
-                <a:ea typeface="Noto Sans CJK KR"/>
-              </a:rPr>
-              <a:t>완성도 높은 소설은 소재·인물·플롯·문체의 4대 축으로 작동한다</a:t>
-            </a:r>
-          </a:p>
-        </p:txBody>
-      </p:sp>
-      <p:sp>
-        <p:nvSpPr>
-          <p:cNvPr id="5" name="TextBox 4"/>
-          <p:cNvSpPr txBox="1"/>
-          <p:nvPr/>
-        </p:nvSpPr>
-        <p:spPr>
-          <a:xfrm>
-            <a:off x="768096" y="923544"/>
-            <a:ext cx="10789920" cy="292608"/>
-          </a:xfrm>
-          <a:prstGeom prst="rect">
-            <a:avLst/>
-          </a:prstGeom>
-          <a:noFill/>
-        </p:spPr>
-        <p:txBody>
-          <a:bodyPr wrap="square" anchor="t" lIns="18288" rIns="18288" tIns="12801" bIns="12801">
-            <a:spAutoFit/>
-          </a:bodyPr>
-          <a:lstStyle/>
-          <a:p>
-            <a:pPr algn="l">
-              <a:lnSpc>
-                <a:spcPct val="125000"/>
-              </a:lnSpc>
-            </a:pPr>
-            <a:r>
-              <a:rPr sz="1200" b="0" i="0">
-                <a:solidFill>
-                  <a:srgbClr val="555E6C"/>
-                </a:solidFill>
-                <a:latin typeface="Noto Sans CJK KR"/>
-                <a:ea typeface="Noto Sans CJK KR"/>
-              </a:rPr>
-              <a:t>네 가지 기둥 중 하나라도 무너지면 서사의 설득력이 급격히 약화된다</a:t>
-            </a:r>
-          </a:p>
-        </p:txBody>
-      </p:sp>
-      <p:sp>
-        <p:nvSpPr>
           <p:cNvPr id="6" name="Rectangle 5"/>
           <p:cNvSpPr/>
           <p:nvPr/>
         </p:nvSpPr>
         <p:spPr>
           <a:xfrm>
-            <a:off x="594360" y="1261872"/>
+            <a:off x="594360" y="1457350"/>
             <a:ext cx="11000232" cy="13716"/>
           </a:xfrm>
           <a:prstGeom prst="rect">
@@ -6189,7 +6269,7 @@
               </a:lnSpc>
             </a:pPr>
             <a:r>
-              <a:rPr sz="1550" b="1" i="0">
+              <a:rPr sz="1250" b="1" i="0">
                 <a:solidFill>
                   <a:srgbClr val="1A212E"/>
                 </a:solidFill>
@@ -6209,7 +6289,7 @@
         </p:nvSpPr>
         <p:spPr>
           <a:xfrm>
-            <a:off x="1453895" y="1874520"/>
+            <a:off x="1453895" y="1911095"/>
             <a:ext cx="4389120" cy="237744"/>
           </a:xfrm>
           <a:prstGeom prst="rect">
@@ -6229,7 +6309,7 @@
               </a:lnSpc>
             </a:pPr>
             <a:r>
-              <a:rPr sz="1080" b="1" i="0">
+              <a:rPr sz="930" b="1" i="0">
                 <a:solidFill>
                   <a:srgbClr val="C6532D"/>
                 </a:solidFill>
@@ -6276,9 +6356,29 @@
                 <a:latin typeface="Noto Sans CJK KR"/>
                 <a:ea typeface="Noto Sans CJK KR"/>
               </a:rPr>
-              <a:t>• 익숙한 일상 속 낯선 균열을 포착해 독자의 질문을 유도
-• 단순한 설정 나열이 아닌 주인공이 겪을 윤리적·현실적 딜레마 내포
-• 한 문장의 로그라인으로 압축될 때 서사의 방향성이 흔들리지 않음</a:t>
+              <a:t>• 익숙한 일상 속 낯선 균열을 포착해 독자의 질문을 유도</a:t>
+            </a:r>
+            <a:br/>
+            <a:r>
+              <a:rPr sz="1080" b="0" i="0">
+                <a:solidFill>
+                  <a:srgbClr val="555E6C"/>
+                </a:solidFill>
+                <a:latin typeface="Noto Sans CJK KR"/>
+                <a:ea typeface="Noto Sans CJK KR"/>
+              </a:rPr>
+              <a:t>• 단순한 설정 나열이 아닌 주인공이 겪을 윤리적·현실적 딜레마 내포</a:t>
+            </a:r>
+            <a:br/>
+            <a:r>
+              <a:rPr sz="1080" b="0" i="0">
+                <a:solidFill>
+                  <a:srgbClr val="555E6C"/>
+                </a:solidFill>
+                <a:latin typeface="Noto Sans CJK KR"/>
+                <a:ea typeface="Noto Sans CJK KR"/>
+              </a:rPr>
+              <a:t>• 한 문장의 로그라인으로 압축될 때 서사의 방향성이 흔들리지 않음</a:t>
             </a:r>
           </a:p>
         </p:txBody>
@@ -6575,7 +6675,7 @@
               </a:lnSpc>
             </a:pPr>
             <a:r>
-              <a:rPr sz="1550" b="1" i="0">
+              <a:rPr sz="1250" b="1" i="0">
                 <a:solidFill>
                   <a:srgbClr val="1A212E"/>
                 </a:solidFill>
@@ -6595,7 +6695,7 @@
         </p:nvSpPr>
         <p:spPr>
           <a:xfrm>
-            <a:off x="7059168" y="1874520"/>
+            <a:off x="7059168" y="1911095"/>
             <a:ext cx="4389120" cy="237744"/>
           </a:xfrm>
           <a:prstGeom prst="rect">
@@ -6615,7 +6715,7 @@
               </a:lnSpc>
             </a:pPr>
             <a:r>
-              <a:rPr sz="1080" b="1" i="0">
+              <a:rPr sz="930" b="1" i="0">
                 <a:solidFill>
                   <a:srgbClr val="316B69"/>
                 </a:solidFill>
@@ -6662,9 +6762,29 @@
                 <a:latin typeface="Noto Sans CJK KR"/>
                 <a:ea typeface="Noto Sans CJK KR"/>
               </a:rPr>
-              <a:t>• 완벽한 영웅보다 결함과 모순을 지닌 인물에게 독자가 감정이입
-• 외면적 목표를 추구하는 과정에서 내면의 거짓 믿음이 깨지는 성장
-• 주인공의 약점을 정확히 파고드는 대립자(Antagonist)와의 상호작용</a:t>
+              <a:t>• 완벽한 영웅보다 결함과 모순을 지닌 인물에게 독자가 감정이입</a:t>
+            </a:r>
+            <a:br/>
+            <a:r>
+              <a:rPr sz="1080" b="0" i="0">
+                <a:solidFill>
+                  <a:srgbClr val="555E6C"/>
+                </a:solidFill>
+                <a:latin typeface="Noto Sans CJK KR"/>
+                <a:ea typeface="Noto Sans CJK KR"/>
+              </a:rPr>
+              <a:t>• 외면적 목표를 추구하는 과정에서 내면의 거짓 믿음이 깨지는 성장</a:t>
+            </a:r>
+            <a:br/>
+            <a:r>
+              <a:rPr sz="1080" b="0" i="0">
+                <a:solidFill>
+                  <a:srgbClr val="555E6C"/>
+                </a:solidFill>
+                <a:latin typeface="Noto Sans CJK KR"/>
+                <a:ea typeface="Noto Sans CJK KR"/>
+              </a:rPr>
+              <a:t>• 주인공의 약점을 정확히 파고드는 대립자(Antagonist)와의 상호작용</a:t>
             </a:r>
           </a:p>
         </p:txBody>
@@ -6961,7 +7081,7 @@
               </a:lnSpc>
             </a:pPr>
             <a:r>
-              <a:rPr sz="1550" b="1" i="0">
+              <a:rPr sz="1250" b="1" i="0">
                 <a:solidFill>
                   <a:srgbClr val="1A212E"/>
                 </a:solidFill>
@@ -6981,7 +7101,7 @@
         </p:nvSpPr>
         <p:spPr>
           <a:xfrm>
-            <a:off x="1453895" y="4087368"/>
+            <a:off x="1453895" y="4123944"/>
             <a:ext cx="4389120" cy="237744"/>
           </a:xfrm>
           <a:prstGeom prst="rect">
@@ -7001,7 +7121,7 @@
               </a:lnSpc>
             </a:pPr>
             <a:r>
-              <a:rPr sz="1080" b="1" i="0">
+              <a:rPr sz="930" b="1" i="0">
                 <a:solidFill>
                   <a:srgbClr val="D19830"/>
                 </a:solidFill>
@@ -7048,9 +7168,29 @@
                 <a:latin typeface="Noto Sans CJK KR"/>
                 <a:ea typeface="Noto Sans CJK KR"/>
               </a:rPr>
-              <a:t>• 우연에 기댄 해결(데우스 엑스 마키나)을 배제하고 인물의 선택으로 전개
-• 점진적으로 판돈(Stakes)을 높여 주인공을 퇴로 없는 막다른 골목으로 압박
-• 3막 구조의 5대 전환점을 통해 긴장과 이완의 서사적 리듬을 설계</a:t>
+              <a:t>• 우연에 기댄 해결(데우스 엑스 마키나)을 배제하고 인물의 선택으로 전개</a:t>
+            </a:r>
+            <a:br/>
+            <a:r>
+              <a:rPr sz="1080" b="0" i="0">
+                <a:solidFill>
+                  <a:srgbClr val="555E6C"/>
+                </a:solidFill>
+                <a:latin typeface="Noto Sans CJK KR"/>
+                <a:ea typeface="Noto Sans CJK KR"/>
+              </a:rPr>
+              <a:t>• 점진적으로 판돈(Stakes)을 높여 주인공을 퇴로 없는 막다른 골목으로 압박</a:t>
+            </a:r>
+            <a:br/>
+            <a:r>
+              <a:rPr sz="1080" b="0" i="0">
+                <a:solidFill>
+                  <a:srgbClr val="555E6C"/>
+                </a:solidFill>
+                <a:latin typeface="Noto Sans CJK KR"/>
+                <a:ea typeface="Noto Sans CJK KR"/>
+              </a:rPr>
+              <a:t>• 3막 구조의 5대 전환점을 통해 긴장과 이완의 서사적 리듬을 설계</a:t>
             </a:r>
           </a:p>
         </p:txBody>
@@ -7347,7 +7487,7 @@
               </a:lnSpc>
             </a:pPr>
             <a:r>
-              <a:rPr sz="1550" b="1" i="0">
+              <a:rPr sz="1250" b="1" i="0">
                 <a:solidFill>
                   <a:srgbClr val="1A212E"/>
                 </a:solidFill>
@@ -7367,7 +7507,7 @@
         </p:nvSpPr>
         <p:spPr>
           <a:xfrm>
-            <a:off x="7059168" y="4087368"/>
+            <a:off x="7059168" y="4123944"/>
             <a:ext cx="4389120" cy="237744"/>
           </a:xfrm>
           <a:prstGeom prst="rect">
@@ -7387,7 +7527,7 @@
               </a:lnSpc>
             </a:pPr>
             <a:r>
-              <a:rPr sz="1080" b="1" i="0">
+              <a:rPr sz="930" b="1" i="0">
                 <a:solidFill>
                   <a:srgbClr val="8E3542"/>
                 </a:solidFill>
@@ -7434,9 +7574,29 @@
                 <a:latin typeface="Noto Sans CJK KR"/>
                 <a:ea typeface="Noto Sans CJK KR"/>
               </a:rPr>
-              <a:t>• 오감의 디테일과 구체적 행동으로 인물의 감정선을 시각화
-• 인물의 성격과 관계의 권력 구도가 묻어나는 입체적인 대사 설계
-• 불필요한 수식어를 덜어내고 장면의 속도에 맞춘 문장 호흡 조율</a:t>
+              <a:t>• 오감의 디테일과 구체적 행동으로 인물의 감정선을 시각화</a:t>
+            </a:r>
+            <a:br/>
+            <a:r>
+              <a:rPr sz="1080" b="0" i="0">
+                <a:solidFill>
+                  <a:srgbClr val="555E6C"/>
+                </a:solidFill>
+                <a:latin typeface="Noto Sans CJK KR"/>
+                <a:ea typeface="Noto Sans CJK KR"/>
+              </a:rPr>
+              <a:t>• 인물의 성격과 관계의 권력 구도가 묻어나는 입체적인 대사 설계</a:t>
+            </a:r>
+            <a:br/>
+            <a:r>
+              <a:rPr sz="1080" b="0" i="0">
+                <a:solidFill>
+                  <a:srgbClr val="555E6C"/>
+                </a:solidFill>
+                <a:latin typeface="Noto Sans CJK KR"/>
+                <a:ea typeface="Noto Sans CJK KR"/>
+              </a:rPr>
+              <a:t>• 불필요한 수식어를 덜어내고 장면의 속도에 맞춘 문장 호흡 조율</a:t>
             </a:r>
           </a:p>
         </p:txBody>
@@ -7641,14 +7801,134 @@
       <p:grpSpPr/>
       <p:sp>
         <p:nvSpPr>
-          <p:cNvPr id="2" name="Rectangle 1"/>
+          <p:cNvPr id="2" name="TextBox 1"/>
+          <p:cNvSpPr txBox="1"/>
+          <p:nvPr/>
+        </p:nvSpPr>
+        <p:spPr>
+          <a:xfrm>
+            <a:off x="768096" y="329184"/>
+            <a:ext cx="10789920" cy="219760"/>
+          </a:xfrm>
+          <a:prstGeom prst="rect">
+            <a:avLst/>
+          </a:prstGeom>
+          <a:noFill/>
+        </p:spPr>
+        <p:txBody>
+          <a:bodyPr wrap="square" anchor="t" lIns="18288" rIns="18288" tIns="12801" bIns="12801">
+            <a:spAutoFit/>
+          </a:bodyPr>
+          <a:lstStyle/>
+          <a:p>
+            <a:pPr algn="l">
+              <a:lnSpc>
+                <a:spcPct val="125000"/>
+              </a:lnSpc>
+            </a:pPr>
+            <a:r>
+              <a:rPr sz="800" b="1" i="0">
+                <a:solidFill>
+                  <a:srgbClr val="C6532D"/>
+                </a:solidFill>
+                <a:latin typeface="Noto Sans CJK KR"/>
+                <a:ea typeface="Noto Sans CJK KR"/>
+              </a:rPr>
+              <a:t>02  |  IDEA &amp; LOGLINE DESIGN</a:t>
+            </a:r>
+          </a:p>
+        </p:txBody>
+      </p:sp>
+      <p:sp>
+        <p:nvSpPr>
+          <p:cNvPr id="3" name="TextBox 2"/>
+          <p:cNvSpPr txBox="1"/>
+          <p:nvPr/>
+        </p:nvSpPr>
+        <p:spPr>
+          <a:xfrm>
+            <a:off x="768096" y="631240"/>
+            <a:ext cx="10789920" cy="423164"/>
+          </a:xfrm>
+          <a:prstGeom prst="rect">
+            <a:avLst/>
+          </a:prstGeom>
+          <a:noFill/>
+        </p:spPr>
+        <p:txBody>
+          <a:bodyPr wrap="square" anchor="t" lIns="18288" rIns="18288" tIns="12801" bIns="12801">
+            <a:spAutoFit/>
+          </a:bodyPr>
+          <a:lstStyle/>
+          <a:p>
+            <a:pPr algn="l">
+              <a:lnSpc>
+                <a:spcPct val="125000"/>
+              </a:lnSpc>
+            </a:pPr>
+            <a:r>
+              <a:rPr sz="1700" b="1" i="0">
+                <a:solidFill>
+                  <a:srgbClr val="1A212E"/>
+                </a:solidFill>
+                <a:latin typeface="Noto Sans CJK KR"/>
+                <a:ea typeface="Noto Sans CJK KR"/>
+              </a:rPr>
+              <a:t>막연한 소재를 한 문장의 로그라인(Logline)으로 압축해 서사의 나침반을 세운다</a:t>
+            </a:r>
+          </a:p>
+        </p:txBody>
+      </p:sp>
+      <p:sp>
+        <p:nvSpPr>
+          <p:cNvPr id="4" name="TextBox 3"/>
+          <p:cNvSpPr txBox="1"/>
+          <p:nvPr/>
+        </p:nvSpPr>
+        <p:spPr>
+          <a:xfrm>
+            <a:off x="768096" y="1136700"/>
+            <a:ext cx="10789920" cy="247497"/>
+          </a:xfrm>
+          <a:prstGeom prst="rect">
+            <a:avLst/>
+          </a:prstGeom>
+          <a:noFill/>
+        </p:spPr>
+        <p:txBody>
+          <a:bodyPr wrap="square" anchor="t" lIns="18288" rIns="18288" tIns="12801" bIns="12801">
+            <a:spAutoFit/>
+          </a:bodyPr>
+          <a:lstStyle/>
+          <a:p>
+            <a:pPr algn="l">
+              <a:lnSpc>
+                <a:spcPct val="125000"/>
+              </a:lnSpc>
+            </a:pPr>
+            <a:r>
+              <a:rPr sz="950" b="0" i="0">
+                <a:solidFill>
+                  <a:srgbClr val="555E6C"/>
+                </a:solidFill>
+                <a:latin typeface="Noto Sans CJK KR"/>
+                <a:ea typeface="Noto Sans CJK KR"/>
+              </a:rPr>
+              <a:t>좋은 로그라인은 주인공, 촉발 사건, 핵심 목표, 그리고 실패 시 치러야 할 대가(Stakes)를 명확히 보여준다</a:t>
+            </a:r>
+          </a:p>
+        </p:txBody>
+      </p:sp>
+      <p:sp>
+        <p:nvSpPr>
+          <p:cNvPr id="5" name="Rectangle 4"/>
           <p:cNvSpPr/>
           <p:nvPr/>
         </p:nvSpPr>
         <p:spPr>
           <a:xfrm>
             <a:off x="594360" y="384048"/>
-            <a:ext cx="73152" cy="713232"/>
+            <a:ext cx="73152" cy="917854"/>
           </a:xfrm>
           <a:prstGeom prst="rect">
             <a:avLst/>
@@ -7685,133 +7965,13 @@
       </p:sp>
       <p:sp>
         <p:nvSpPr>
-          <p:cNvPr id="3" name="TextBox 2"/>
-          <p:cNvSpPr txBox="1"/>
-          <p:nvPr/>
-        </p:nvSpPr>
-        <p:spPr>
-          <a:xfrm>
-            <a:off x="768096" y="329184"/>
-            <a:ext cx="8229600" cy="256032"/>
-          </a:xfrm>
-          <a:prstGeom prst="rect">
-            <a:avLst/>
-          </a:prstGeom>
-          <a:noFill/>
-        </p:spPr>
-        <p:txBody>
-          <a:bodyPr wrap="square" anchor="t" lIns="18288" rIns="18288" tIns="12801" bIns="12801">
-            <a:spAutoFit/>
-          </a:bodyPr>
-          <a:lstStyle/>
-          <a:p>
-            <a:pPr algn="l">
-              <a:lnSpc>
-                <a:spcPct val="125000"/>
-              </a:lnSpc>
-            </a:pPr>
-            <a:r>
-              <a:rPr sz="1050" b="1" i="0">
-                <a:solidFill>
-                  <a:srgbClr val="C6532D"/>
-                </a:solidFill>
-                <a:latin typeface="Noto Sans CJK KR"/>
-                <a:ea typeface="Noto Sans CJK KR"/>
-              </a:rPr>
-              <a:t>02  |  IDEA &amp; LOGLINE DESIGN</a:t>
-            </a:r>
-          </a:p>
-        </p:txBody>
-      </p:sp>
-      <p:sp>
-        <p:nvSpPr>
-          <p:cNvPr id="4" name="TextBox 3"/>
-          <p:cNvSpPr txBox="1"/>
-          <p:nvPr/>
-        </p:nvSpPr>
-        <p:spPr>
-          <a:xfrm>
-            <a:off x="768096" y="548640"/>
-            <a:ext cx="10789920" cy="402336"/>
-          </a:xfrm>
-          <a:prstGeom prst="rect">
-            <a:avLst/>
-          </a:prstGeom>
-          <a:noFill/>
-        </p:spPr>
-        <p:txBody>
-          <a:bodyPr wrap="square" anchor="t" lIns="18288" rIns="18288" tIns="12801" bIns="12801">
-            <a:spAutoFit/>
-          </a:bodyPr>
-          <a:lstStyle/>
-          <a:p>
-            <a:pPr algn="l">
-              <a:lnSpc>
-                <a:spcPct val="125000"/>
-              </a:lnSpc>
-            </a:pPr>
-            <a:r>
-              <a:rPr sz="2150" b="1" i="0">
-                <a:solidFill>
-                  <a:srgbClr val="1A212E"/>
-                </a:solidFill>
-                <a:latin typeface="Noto Sans CJK KR"/>
-                <a:ea typeface="Noto Sans CJK KR"/>
-              </a:rPr>
-              <a:t>막연한 소재를 한 문장의 로그라인(Logline)으로 압축해 서사의 나침반을 세운다</a:t>
-            </a:r>
-          </a:p>
-        </p:txBody>
-      </p:sp>
-      <p:sp>
-        <p:nvSpPr>
-          <p:cNvPr id="5" name="TextBox 4"/>
-          <p:cNvSpPr txBox="1"/>
-          <p:nvPr/>
-        </p:nvSpPr>
-        <p:spPr>
-          <a:xfrm>
-            <a:off x="768096" y="923544"/>
-            <a:ext cx="10789920" cy="292608"/>
-          </a:xfrm>
-          <a:prstGeom prst="rect">
-            <a:avLst/>
-          </a:prstGeom>
-          <a:noFill/>
-        </p:spPr>
-        <p:txBody>
-          <a:bodyPr wrap="square" anchor="t" lIns="18288" rIns="18288" tIns="12801" bIns="12801">
-            <a:spAutoFit/>
-          </a:bodyPr>
-          <a:lstStyle/>
-          <a:p>
-            <a:pPr algn="l">
-              <a:lnSpc>
-                <a:spcPct val="125000"/>
-              </a:lnSpc>
-            </a:pPr>
-            <a:r>
-              <a:rPr sz="1200" b="0" i="0">
-                <a:solidFill>
-                  <a:srgbClr val="555E6C"/>
-                </a:solidFill>
-                <a:latin typeface="Noto Sans CJK KR"/>
-                <a:ea typeface="Noto Sans CJK KR"/>
-              </a:rPr>
-              <a:t>좋은 로그라인은 주인공, 촉발 사건, 핵심 목표, 그리고 실패 시 치러야 할 대가(Stakes)를 명확히 보여준다</a:t>
-            </a:r>
-          </a:p>
-        </p:txBody>
-      </p:sp>
-      <p:sp>
-        <p:nvSpPr>
           <p:cNvPr id="6" name="Rectangle 5"/>
           <p:cNvSpPr/>
           <p:nvPr/>
         </p:nvSpPr>
         <p:spPr>
           <a:xfrm>
-            <a:off x="594360" y="1261872"/>
+            <a:off x="594360" y="1457350"/>
             <a:ext cx="11000232" cy="13716"/>
           </a:xfrm>
           <a:prstGeom prst="rect">
@@ -8047,7 +8207,7 @@
               </a:lnSpc>
             </a:pPr>
             <a:r>
-              <a:rPr sz="1150" b="1" i="0">
+              <a:rPr sz="1050" b="1" i="0">
                 <a:solidFill>
                   <a:srgbClr val="C6532D"/>
                 </a:solidFill>
@@ -8215,7 +8375,7 @@
               </a:lnSpc>
             </a:pPr>
             <a:r>
-              <a:rPr sz="1800" b="1" i="0">
+              <a:rPr sz="1250" b="1" i="0">
                 <a:solidFill>
                   <a:srgbClr val="C6532D"/>
                 </a:solidFill>
@@ -8383,7 +8543,7 @@
               </a:lnSpc>
             </a:pPr>
             <a:r>
-              <a:rPr sz="1800" b="1" i="0">
+              <a:rPr sz="1250" b="1" i="0">
                 <a:solidFill>
                   <a:srgbClr val="C6532D"/>
                 </a:solidFill>
@@ -8551,7 +8711,7 @@
               </a:lnSpc>
             </a:pPr>
             <a:r>
-              <a:rPr sz="1800" b="1" i="0">
+              <a:rPr sz="1250" b="1" i="0">
                 <a:solidFill>
                   <a:srgbClr val="C6532D"/>
                 </a:solidFill>
@@ -8719,7 +8879,7 @@
               </a:lnSpc>
             </a:pPr>
             <a:r>
-              <a:rPr sz="1350" b="1" i="0">
+              <a:rPr sz="1200" b="1" i="0">
                 <a:solidFill>
                   <a:srgbClr val="1A212E"/>
                 </a:solidFill>
@@ -8807,7 +8967,7 @@
               </a:lnSpc>
             </a:pPr>
             <a:r>
-              <a:rPr sz="980" b="1" i="0">
+              <a:rPr sz="880" b="1" i="0">
                 <a:solidFill>
                   <a:srgbClr val="878E99"/>
                 </a:solidFill>
@@ -8887,7 +9047,7 @@
               </a:lnSpc>
             </a:pPr>
             <a:r>
-              <a:rPr sz="2000" b="1" i="0">
+              <a:rPr sz="1400" b="1" i="0">
                 <a:solidFill>
                   <a:srgbClr val="C6532D"/>
                 </a:solidFill>
@@ -9019,7 +9179,7 @@
               </a:lnSpc>
             </a:pPr>
             <a:r>
-              <a:rPr sz="980" b="1" i="0">
+              <a:rPr sz="880" b="1" i="0">
                 <a:solidFill>
                   <a:srgbClr val="C6532D"/>
                 </a:solidFill>
@@ -9040,7 +9200,7 @@
         <p:spPr>
           <a:xfrm>
             <a:off x="8915400" y="3401568"/>
-            <a:ext cx="2542032" cy="219456"/>
+            <a:ext cx="2542032" cy="246888"/>
           </a:xfrm>
           <a:prstGeom prst="roundRect">
             <a:avLst>
@@ -9086,7 +9246,7 @@
         <p:spPr>
           <a:xfrm>
             <a:off x="8915400" y="3401568"/>
-            <a:ext cx="2542032" cy="219456"/>
+            <a:ext cx="2542032" cy="246888"/>
           </a:xfrm>
           <a:prstGeom prst="rect">
             <a:avLst/>
@@ -9101,7 +9261,7 @@
           <a:p>
             <a:pPr algn="ctr">
               <a:lnSpc>
-                <a:spcPct val="125000"/>
+                <a:spcPct val="100000"/>
               </a:lnSpc>
             </a:pPr>
             <a:r>
@@ -9233,7 +9393,7 @@
               </a:lnSpc>
             </a:pPr>
             <a:r>
-              <a:rPr sz="980" b="1" i="0">
+              <a:rPr sz="880" b="1" i="0">
                 <a:solidFill>
                   <a:srgbClr val="878E99"/>
                 </a:solidFill>
@@ -9313,7 +9473,7 @@
               </a:lnSpc>
             </a:pPr>
             <a:r>
-              <a:rPr sz="2000" b="1" i="0">
+              <a:rPr sz="1400" b="1" i="0">
                 <a:solidFill>
                   <a:srgbClr val="C6532D"/>
                 </a:solidFill>
@@ -9445,7 +9605,7 @@
               </a:lnSpc>
             </a:pPr>
             <a:r>
-              <a:rPr sz="980" b="1" i="0">
+              <a:rPr sz="880" b="1" i="0">
                 <a:solidFill>
                   <a:srgbClr val="C6532D"/>
                 </a:solidFill>
@@ -9466,7 +9626,7 @@
         <p:spPr>
           <a:xfrm>
             <a:off x="8915400" y="4389120"/>
-            <a:ext cx="2542032" cy="219456"/>
+            <a:ext cx="2542032" cy="246888"/>
           </a:xfrm>
           <a:prstGeom prst="roundRect">
             <a:avLst>
@@ -9512,7 +9672,7 @@
         <p:spPr>
           <a:xfrm>
             <a:off x="8915400" y="4389120"/>
-            <a:ext cx="2542032" cy="219456"/>
+            <a:ext cx="2542032" cy="246888"/>
           </a:xfrm>
           <a:prstGeom prst="rect">
             <a:avLst/>
@@ -9527,7 +9687,7 @@
           <a:p>
             <a:pPr algn="ctr">
               <a:lnSpc>
-                <a:spcPct val="125000"/>
+                <a:spcPct val="100000"/>
               </a:lnSpc>
             </a:pPr>
             <a:r>
@@ -9659,7 +9819,7 @@
               </a:lnSpc>
             </a:pPr>
             <a:r>
-              <a:rPr sz="980" b="1" i="0">
+              <a:rPr sz="880" b="1" i="0">
                 <a:solidFill>
                   <a:srgbClr val="878E99"/>
                 </a:solidFill>
@@ -9739,7 +9899,7 @@
               </a:lnSpc>
             </a:pPr>
             <a:r>
-              <a:rPr sz="2000" b="1" i="0">
+              <a:rPr sz="1400" b="1" i="0">
                 <a:solidFill>
                   <a:srgbClr val="C6532D"/>
                 </a:solidFill>
@@ -9871,7 +10031,7 @@
               </a:lnSpc>
             </a:pPr>
             <a:r>
-              <a:rPr sz="980" b="1" i="0">
+              <a:rPr sz="880" b="1" i="0">
                 <a:solidFill>
                   <a:srgbClr val="C6532D"/>
                 </a:solidFill>
@@ -9892,7 +10052,7 @@
         <p:spPr>
           <a:xfrm>
             <a:off x="8915400" y="5376672"/>
-            <a:ext cx="2542032" cy="219456"/>
+            <a:ext cx="2542032" cy="246888"/>
           </a:xfrm>
           <a:prstGeom prst="roundRect">
             <a:avLst>
@@ -9938,7 +10098,7 @@
         <p:spPr>
           <a:xfrm>
             <a:off x="8915400" y="5376672"/>
-            <a:ext cx="2542032" cy="219456"/>
+            <a:ext cx="2542032" cy="246888"/>
           </a:xfrm>
           <a:prstGeom prst="rect">
             <a:avLst/>
@@ -9953,7 +10113,7 @@
           <a:p>
             <a:pPr algn="ctr">
               <a:lnSpc>
-                <a:spcPct val="125000"/>
+                <a:spcPct val="100000"/>
               </a:lnSpc>
             </a:pPr>
             <a:r>
@@ -10037,14 +10197,134 @@
       <p:grpSpPr/>
       <p:sp>
         <p:nvSpPr>
-          <p:cNvPr id="2" name="Rectangle 1"/>
+          <p:cNvPr id="2" name="TextBox 1"/>
+          <p:cNvSpPr txBox="1"/>
+          <p:nvPr/>
+        </p:nvSpPr>
+        <p:spPr>
+          <a:xfrm>
+            <a:off x="768096" y="329184"/>
+            <a:ext cx="10789920" cy="219760"/>
+          </a:xfrm>
+          <a:prstGeom prst="rect">
+            <a:avLst/>
+          </a:prstGeom>
+          <a:noFill/>
+        </p:spPr>
+        <p:txBody>
+          <a:bodyPr wrap="square" anchor="t" lIns="18288" rIns="18288" tIns="12801" bIns="12801">
+            <a:spAutoFit/>
+          </a:bodyPr>
+          <a:lstStyle/>
+          <a:p>
+            <a:pPr algn="l">
+              <a:lnSpc>
+                <a:spcPct val="125000"/>
+              </a:lnSpc>
+            </a:pPr>
+            <a:r>
+              <a:rPr sz="800" b="1" i="0">
+                <a:solidFill>
+                  <a:srgbClr val="C6532D"/>
+                </a:solidFill>
+                <a:latin typeface="Noto Sans CJK KR"/>
+                <a:ea typeface="Noto Sans CJK KR"/>
+              </a:rPr>
+              <a:t>03  |  CHARACTER PSYCHOLOGY</a:t>
+            </a:r>
+          </a:p>
+        </p:txBody>
+      </p:sp>
+      <p:sp>
+        <p:nvSpPr>
+          <p:cNvPr id="3" name="TextBox 2"/>
+          <p:cNvSpPr txBox="1"/>
+          <p:nvPr/>
+        </p:nvSpPr>
+        <p:spPr>
+          <a:xfrm>
+            <a:off x="768096" y="631240"/>
+            <a:ext cx="10789920" cy="423164"/>
+          </a:xfrm>
+          <a:prstGeom prst="rect">
+            <a:avLst/>
+          </a:prstGeom>
+          <a:noFill/>
+        </p:spPr>
+        <p:txBody>
+          <a:bodyPr wrap="square" anchor="t" lIns="18288" rIns="18288" tIns="12801" bIns="12801">
+            <a:spAutoFit/>
+          </a:bodyPr>
+          <a:lstStyle/>
+          <a:p>
+            <a:pPr algn="l">
+              <a:lnSpc>
+                <a:spcPct val="125000"/>
+              </a:lnSpc>
+            </a:pPr>
+            <a:r>
+              <a:rPr sz="1700" b="1" i="0">
+                <a:solidFill>
+                  <a:srgbClr val="1A212E"/>
+                </a:solidFill>
+                <a:latin typeface="Noto Sans CJK KR"/>
+                <a:ea typeface="Noto Sans CJK KR"/>
+              </a:rPr>
+              <a:t>독자가 사랑하는 인물은 외면적 목표(Want)와 내면적 결핍(Need)의 간극에서 탄생한다</a:t>
+            </a:r>
+          </a:p>
+        </p:txBody>
+      </p:sp>
+      <p:sp>
+        <p:nvSpPr>
+          <p:cNvPr id="4" name="TextBox 3"/>
+          <p:cNvSpPr txBox="1"/>
+          <p:nvPr/>
+        </p:nvSpPr>
+        <p:spPr>
+          <a:xfrm>
+            <a:off x="768096" y="1136700"/>
+            <a:ext cx="10789920" cy="247497"/>
+          </a:xfrm>
+          <a:prstGeom prst="rect">
+            <a:avLst/>
+          </a:prstGeom>
+          <a:noFill/>
+        </p:spPr>
+        <p:txBody>
+          <a:bodyPr wrap="square" anchor="t" lIns="18288" rIns="18288" tIns="12801" bIns="12801">
+            <a:spAutoFit/>
+          </a:bodyPr>
+          <a:lstStyle/>
+          <a:p>
+            <a:pPr algn="l">
+              <a:lnSpc>
+                <a:spcPct val="125000"/>
+              </a:lnSpc>
+            </a:pPr>
+            <a:r>
+              <a:rPr sz="950" b="0" i="0">
+                <a:solidFill>
+                  <a:srgbClr val="555E6C"/>
+                </a:solidFill>
+                <a:latin typeface="Noto Sans CJK KR"/>
+                <a:ea typeface="Noto Sans CJK KR"/>
+              </a:rPr>
+              <a:t>인물의 프로필을 나열하는 대신, 과거의 상처(Ghost)가 만든 거짓 믿음(Lie)과 행동 동기를 설계하라</a:t>
+            </a:r>
+          </a:p>
+        </p:txBody>
+      </p:sp>
+      <p:sp>
+        <p:nvSpPr>
+          <p:cNvPr id="5" name="Rectangle 4"/>
           <p:cNvSpPr/>
           <p:nvPr/>
         </p:nvSpPr>
         <p:spPr>
           <a:xfrm>
             <a:off x="594360" y="384048"/>
-            <a:ext cx="73152" cy="713232"/>
+            <a:ext cx="73152" cy="917854"/>
           </a:xfrm>
           <a:prstGeom prst="rect">
             <a:avLst/>
@@ -10081,133 +10361,13 @@
       </p:sp>
       <p:sp>
         <p:nvSpPr>
-          <p:cNvPr id="3" name="TextBox 2"/>
-          <p:cNvSpPr txBox="1"/>
-          <p:nvPr/>
-        </p:nvSpPr>
-        <p:spPr>
-          <a:xfrm>
-            <a:off x="768096" y="329184"/>
-            <a:ext cx="8229600" cy="256032"/>
-          </a:xfrm>
-          <a:prstGeom prst="rect">
-            <a:avLst/>
-          </a:prstGeom>
-          <a:noFill/>
-        </p:spPr>
-        <p:txBody>
-          <a:bodyPr wrap="square" anchor="t" lIns="18288" rIns="18288" tIns="12801" bIns="12801">
-            <a:spAutoFit/>
-          </a:bodyPr>
-          <a:lstStyle/>
-          <a:p>
-            <a:pPr algn="l">
-              <a:lnSpc>
-                <a:spcPct val="125000"/>
-              </a:lnSpc>
-            </a:pPr>
-            <a:r>
-              <a:rPr sz="1050" b="1" i="0">
-                <a:solidFill>
-                  <a:srgbClr val="C6532D"/>
-                </a:solidFill>
-                <a:latin typeface="Noto Sans CJK KR"/>
-                <a:ea typeface="Noto Sans CJK KR"/>
-              </a:rPr>
-              <a:t>03  |  CHARACTER PSYCHOLOGY</a:t>
-            </a:r>
-          </a:p>
-        </p:txBody>
-      </p:sp>
-      <p:sp>
-        <p:nvSpPr>
-          <p:cNvPr id="4" name="TextBox 3"/>
-          <p:cNvSpPr txBox="1"/>
-          <p:nvPr/>
-        </p:nvSpPr>
-        <p:spPr>
-          <a:xfrm>
-            <a:off x="768096" y="548640"/>
-            <a:ext cx="10789920" cy="402336"/>
-          </a:xfrm>
-          <a:prstGeom prst="rect">
-            <a:avLst/>
-          </a:prstGeom>
-          <a:noFill/>
-        </p:spPr>
-        <p:txBody>
-          <a:bodyPr wrap="square" anchor="t" lIns="18288" rIns="18288" tIns="12801" bIns="12801">
-            <a:spAutoFit/>
-          </a:bodyPr>
-          <a:lstStyle/>
-          <a:p>
-            <a:pPr algn="l">
-              <a:lnSpc>
-                <a:spcPct val="125000"/>
-              </a:lnSpc>
-            </a:pPr>
-            <a:r>
-              <a:rPr sz="2150" b="1" i="0">
-                <a:solidFill>
-                  <a:srgbClr val="1A212E"/>
-                </a:solidFill>
-                <a:latin typeface="Noto Sans CJK KR"/>
-                <a:ea typeface="Noto Sans CJK KR"/>
-              </a:rPr>
-              <a:t>독자가 사랑하는 인물은 외면적 목표(Want)와 내면적 결핍(Need)의 간극에서 탄생한다</a:t>
-            </a:r>
-          </a:p>
-        </p:txBody>
-      </p:sp>
-      <p:sp>
-        <p:nvSpPr>
-          <p:cNvPr id="5" name="TextBox 4"/>
-          <p:cNvSpPr txBox="1"/>
-          <p:nvPr/>
-        </p:nvSpPr>
-        <p:spPr>
-          <a:xfrm>
-            <a:off x="768096" y="923544"/>
-            <a:ext cx="10789920" cy="292608"/>
-          </a:xfrm>
-          <a:prstGeom prst="rect">
-            <a:avLst/>
-          </a:prstGeom>
-          <a:noFill/>
-        </p:spPr>
-        <p:txBody>
-          <a:bodyPr wrap="square" anchor="t" lIns="18288" rIns="18288" tIns="12801" bIns="12801">
-            <a:spAutoFit/>
-          </a:bodyPr>
-          <a:lstStyle/>
-          <a:p>
-            <a:pPr algn="l">
-              <a:lnSpc>
-                <a:spcPct val="125000"/>
-              </a:lnSpc>
-            </a:pPr>
-            <a:r>
-              <a:rPr sz="1200" b="0" i="0">
-                <a:solidFill>
-                  <a:srgbClr val="555E6C"/>
-                </a:solidFill>
-                <a:latin typeface="Noto Sans CJK KR"/>
-                <a:ea typeface="Noto Sans CJK KR"/>
-              </a:rPr>
-              <a:t>인물의 프로필을 나열하는 대신, 과거의 상처(Ghost)가 만든 거짓 믿음(Lie)과 행동 동기를 설계하라</a:t>
-            </a:r>
-          </a:p>
-        </p:txBody>
-      </p:sp>
-      <p:sp>
-        <p:nvSpPr>
           <p:cNvPr id="6" name="Rectangle 5"/>
           <p:cNvSpPr/>
           <p:nvPr/>
         </p:nvSpPr>
         <p:spPr>
           <a:xfrm>
-            <a:off x="594360" y="1261872"/>
+            <a:off x="594360" y="1457350"/>
             <a:ext cx="11000232" cy="13716"/>
           </a:xfrm>
           <a:prstGeom prst="rect">
@@ -10443,7 +10603,7 @@
               </a:lnSpc>
             </a:pPr>
             <a:r>
-              <a:rPr sz="1300" b="1" i="0">
+              <a:rPr sz="1200" b="1" i="0">
                 <a:solidFill>
                   <a:srgbClr val="1A212E"/>
                 </a:solidFill>
@@ -10599,7 +10759,7 @@
               </a:lnSpc>
             </a:pPr>
             <a:r>
-              <a:rPr sz="1300" b="1" i="0">
+              <a:rPr sz="1050" b="1" i="0">
                 <a:solidFill>
                   <a:srgbClr val="1A212E"/>
                 </a:solidFill>
@@ -10639,7 +10799,7 @@
               </a:lnSpc>
             </a:pPr>
             <a:r>
-              <a:rPr sz="1060" b="0" i="0">
+              <a:rPr sz="1010" b="0" i="0">
                 <a:solidFill>
                   <a:srgbClr val="555E6C"/>
                 </a:solidFill>
@@ -10771,7 +10931,7 @@
               </a:lnSpc>
             </a:pPr>
             <a:r>
-              <a:rPr sz="1300" b="1" i="0">
+              <a:rPr sz="1050" b="1" i="0">
                 <a:solidFill>
                   <a:srgbClr val="1A212E"/>
                 </a:solidFill>
@@ -10811,7 +10971,7 @@
               </a:lnSpc>
             </a:pPr>
             <a:r>
-              <a:rPr sz="1060" b="0" i="0">
+              <a:rPr sz="1010" b="0" i="0">
                 <a:solidFill>
                   <a:srgbClr val="555E6C"/>
                 </a:solidFill>
@@ -10943,7 +11103,7 @@
               </a:lnSpc>
             </a:pPr>
             <a:r>
-              <a:rPr sz="1300" b="1" i="0">
+              <a:rPr sz="1050" b="1" i="0">
                 <a:solidFill>
                   <a:srgbClr val="1A212E"/>
                 </a:solidFill>
@@ -10983,7 +11143,7 @@
               </a:lnSpc>
             </a:pPr>
             <a:r>
-              <a:rPr sz="1060" b="0" i="0">
+              <a:rPr sz="1010" b="0" i="0">
                 <a:solidFill>
                   <a:srgbClr val="555E6C"/>
                 </a:solidFill>
@@ -11069,7 +11229,7 @@
               </a:lnSpc>
             </a:pPr>
             <a:r>
-              <a:rPr sz="1200" b="1" i="0">
+              <a:rPr sz="1050" b="1" i="0">
                 <a:solidFill>
                   <a:srgbClr val="D19830"/>
                 </a:solidFill>
@@ -11429,14 +11589,134 @@
       <p:grpSpPr/>
       <p:sp>
         <p:nvSpPr>
-          <p:cNvPr id="2" name="Rectangle 1"/>
+          <p:cNvPr id="2" name="TextBox 1"/>
+          <p:cNvSpPr txBox="1"/>
+          <p:nvPr/>
+        </p:nvSpPr>
+        <p:spPr>
+          <a:xfrm>
+            <a:off x="768096" y="329184"/>
+            <a:ext cx="10789920" cy="219760"/>
+          </a:xfrm>
+          <a:prstGeom prst="rect">
+            <a:avLst/>
+          </a:prstGeom>
+          <a:noFill/>
+        </p:spPr>
+        <p:txBody>
+          <a:bodyPr wrap="square" anchor="t" lIns="18288" rIns="18288" tIns="12801" bIns="12801">
+            <a:spAutoFit/>
+          </a:bodyPr>
+          <a:lstStyle/>
+          <a:p>
+            <a:pPr algn="l">
+              <a:lnSpc>
+                <a:spcPct val="125000"/>
+              </a:lnSpc>
+            </a:pPr>
+            <a:r>
+              <a:rPr sz="800" b="1" i="0">
+                <a:solidFill>
+                  <a:srgbClr val="C6532D"/>
+                </a:solidFill>
+                <a:latin typeface="Noto Sans CJK KR"/>
+                <a:ea typeface="Noto Sans CJK KR"/>
+              </a:rPr>
+              <a:t>04  |  THREE-ACT STRUCTURE &amp; PLOT BEATS</a:t>
+            </a:r>
+          </a:p>
+        </p:txBody>
+      </p:sp>
+      <p:sp>
+        <p:nvSpPr>
+          <p:cNvPr id="3" name="TextBox 2"/>
+          <p:cNvSpPr txBox="1"/>
+          <p:nvPr/>
+        </p:nvSpPr>
+        <p:spPr>
+          <a:xfrm>
+            <a:off x="768096" y="631240"/>
+            <a:ext cx="10789920" cy="423164"/>
+          </a:xfrm>
+          <a:prstGeom prst="rect">
+            <a:avLst/>
+          </a:prstGeom>
+          <a:noFill/>
+        </p:spPr>
+        <p:txBody>
+          <a:bodyPr wrap="square" anchor="t" lIns="18288" rIns="18288" tIns="12801" bIns="12801">
+            <a:spAutoFit/>
+          </a:bodyPr>
+          <a:lstStyle/>
+          <a:p>
+            <a:pPr algn="l">
+              <a:lnSpc>
+                <a:spcPct val="125000"/>
+              </a:lnSpc>
+            </a:pPr>
+            <a:r>
+              <a:rPr sz="1700" b="1" i="0">
+                <a:solidFill>
+                  <a:srgbClr val="1A212E"/>
+                </a:solidFill>
+                <a:latin typeface="Noto Sans CJK KR"/>
+                <a:ea typeface="Noto Sans CJK KR"/>
+              </a:rPr>
+              <a:t>3막 구조와 5대 전환점(Plot Beats)으로 독자가 책을 덮지 못하는 긴장감을 조율한다</a:t>
+            </a:r>
+          </a:p>
+        </p:txBody>
+      </p:sp>
+      <p:sp>
+        <p:nvSpPr>
+          <p:cNvPr id="4" name="TextBox 3"/>
+          <p:cNvSpPr txBox="1"/>
+          <p:nvPr/>
+        </p:nvSpPr>
+        <p:spPr>
+          <a:xfrm>
+            <a:off x="768096" y="1136700"/>
+            <a:ext cx="10789920" cy="247497"/>
+          </a:xfrm>
+          <a:prstGeom prst="rect">
+            <a:avLst/>
+          </a:prstGeom>
+          <a:noFill/>
+        </p:spPr>
+        <p:txBody>
+          <a:bodyPr wrap="square" anchor="t" lIns="18288" rIns="18288" tIns="12801" bIns="12801">
+            <a:spAutoFit/>
+          </a:bodyPr>
+          <a:lstStyle/>
+          <a:p>
+            <a:pPr algn="l">
+              <a:lnSpc>
+                <a:spcPct val="125000"/>
+              </a:lnSpc>
+            </a:pPr>
+            <a:r>
+              <a:rPr sz="950" b="0" i="0">
+                <a:solidFill>
+                  <a:srgbClr val="555E6C"/>
+                </a:solidFill>
+                <a:latin typeface="Noto Sans CJK KR"/>
+                <a:ea typeface="Noto Sans CJK KR"/>
+              </a:rPr>
+              <a:t>서사의 황금 비율(1막 25% : 2막 50% : 3막 25%)을 통해 위기의 고조와 해소의 쾌감을 정교하게 배치한다</a:t>
+            </a:r>
+          </a:p>
+        </p:txBody>
+      </p:sp>
+      <p:sp>
+        <p:nvSpPr>
+          <p:cNvPr id="5" name="Rectangle 4"/>
           <p:cNvSpPr/>
           <p:nvPr/>
         </p:nvSpPr>
         <p:spPr>
           <a:xfrm>
             <a:off x="594360" y="384048"/>
-            <a:ext cx="73152" cy="713232"/>
+            <a:ext cx="73152" cy="917854"/>
           </a:xfrm>
           <a:prstGeom prst="rect">
             <a:avLst/>
@@ -11473,133 +11753,13 @@
       </p:sp>
       <p:sp>
         <p:nvSpPr>
-          <p:cNvPr id="3" name="TextBox 2"/>
-          <p:cNvSpPr txBox="1"/>
-          <p:nvPr/>
-        </p:nvSpPr>
-        <p:spPr>
-          <a:xfrm>
-            <a:off x="768096" y="329184"/>
-            <a:ext cx="8229600" cy="256032"/>
-          </a:xfrm>
-          <a:prstGeom prst="rect">
-            <a:avLst/>
-          </a:prstGeom>
-          <a:noFill/>
-        </p:spPr>
-        <p:txBody>
-          <a:bodyPr wrap="square" anchor="t" lIns="18288" rIns="18288" tIns="12801" bIns="12801">
-            <a:spAutoFit/>
-          </a:bodyPr>
-          <a:lstStyle/>
-          <a:p>
-            <a:pPr algn="l">
-              <a:lnSpc>
-                <a:spcPct val="125000"/>
-              </a:lnSpc>
-            </a:pPr>
-            <a:r>
-              <a:rPr sz="1050" b="1" i="0">
-                <a:solidFill>
-                  <a:srgbClr val="C6532D"/>
-                </a:solidFill>
-                <a:latin typeface="Noto Sans CJK KR"/>
-                <a:ea typeface="Noto Sans CJK KR"/>
-              </a:rPr>
-              <a:t>04  |  THREE-ACT STRUCTURE &amp; PLOT BEATS</a:t>
-            </a:r>
-          </a:p>
-        </p:txBody>
-      </p:sp>
-      <p:sp>
-        <p:nvSpPr>
-          <p:cNvPr id="4" name="TextBox 3"/>
-          <p:cNvSpPr txBox="1"/>
-          <p:nvPr/>
-        </p:nvSpPr>
-        <p:spPr>
-          <a:xfrm>
-            <a:off x="768096" y="548640"/>
-            <a:ext cx="10789920" cy="402336"/>
-          </a:xfrm>
-          <a:prstGeom prst="rect">
-            <a:avLst/>
-          </a:prstGeom>
-          <a:noFill/>
-        </p:spPr>
-        <p:txBody>
-          <a:bodyPr wrap="square" anchor="t" lIns="18288" rIns="18288" tIns="12801" bIns="12801">
-            <a:spAutoFit/>
-          </a:bodyPr>
-          <a:lstStyle/>
-          <a:p>
-            <a:pPr algn="l">
-              <a:lnSpc>
-                <a:spcPct val="125000"/>
-              </a:lnSpc>
-            </a:pPr>
-            <a:r>
-              <a:rPr sz="2150" b="1" i="0">
-                <a:solidFill>
-                  <a:srgbClr val="1A212E"/>
-                </a:solidFill>
-                <a:latin typeface="Noto Sans CJK KR"/>
-                <a:ea typeface="Noto Sans CJK KR"/>
-              </a:rPr>
-              <a:t>3막 구조와 5대 전환점(Plot Beats)으로 독자가 책을 덮지 못하는 긴장감을 조율한다</a:t>
-            </a:r>
-          </a:p>
-        </p:txBody>
-      </p:sp>
-      <p:sp>
-        <p:nvSpPr>
-          <p:cNvPr id="5" name="TextBox 4"/>
-          <p:cNvSpPr txBox="1"/>
-          <p:nvPr/>
-        </p:nvSpPr>
-        <p:spPr>
-          <a:xfrm>
-            <a:off x="768096" y="923544"/>
-            <a:ext cx="10789920" cy="292608"/>
-          </a:xfrm>
-          <a:prstGeom prst="rect">
-            <a:avLst/>
-          </a:prstGeom>
-          <a:noFill/>
-        </p:spPr>
-        <p:txBody>
-          <a:bodyPr wrap="square" anchor="t" lIns="18288" rIns="18288" tIns="12801" bIns="12801">
-            <a:spAutoFit/>
-          </a:bodyPr>
-          <a:lstStyle/>
-          <a:p>
-            <a:pPr algn="l">
-              <a:lnSpc>
-                <a:spcPct val="125000"/>
-              </a:lnSpc>
-            </a:pPr>
-            <a:r>
-              <a:rPr sz="1200" b="0" i="0">
-                <a:solidFill>
-                  <a:srgbClr val="555E6C"/>
-                </a:solidFill>
-                <a:latin typeface="Noto Sans CJK KR"/>
-                <a:ea typeface="Noto Sans CJK KR"/>
-              </a:rPr>
-              <a:t>서사의 황금 비율(1막 25% : 2막 50% : 3막 25%)을 통해 위기의 고조와 해소의 쾌감을 정교하게 배치한다</a:t>
-            </a:r>
-          </a:p>
-        </p:txBody>
-      </p:sp>
-      <p:sp>
-        <p:nvSpPr>
           <p:cNvPr id="6" name="Rectangle 5"/>
           <p:cNvSpPr/>
           <p:nvPr/>
         </p:nvSpPr>
         <p:spPr>
           <a:xfrm>
-            <a:off x="594360" y="1261872"/>
+            <a:off x="594360" y="1457350"/>
             <a:ext cx="11000232" cy="13716"/>
           </a:xfrm>
           <a:prstGeom prst="rect">
@@ -11951,7 +12111,7 @@
               </a:lnSpc>
             </a:pPr>
             <a:r>
-              <a:rPr sz="1150" b="1" i="0">
+              <a:rPr sz="1050" b="1" i="0">
                 <a:solidFill>
                   <a:srgbClr val="C6532D"/>
                 </a:solidFill>
@@ -11991,7 +12151,7 @@
               </a:lnSpc>
             </a:pPr>
             <a:r>
-              <a:rPr sz="1100" b="1" i="0">
+              <a:rPr sz="950" b="1" i="0">
                 <a:solidFill>
                   <a:srgbClr val="1A212E"/>
                 </a:solidFill>
@@ -12163,7 +12323,7 @@
               </a:lnSpc>
             </a:pPr>
             <a:r>
-              <a:rPr sz="1150" b="1" i="0">
+              <a:rPr sz="1050" b="1" i="0">
                 <a:solidFill>
                   <a:srgbClr val="316B69"/>
                 </a:solidFill>
@@ -12203,7 +12363,7 @@
               </a:lnSpc>
             </a:pPr>
             <a:r>
-              <a:rPr sz="1100" b="1" i="0">
+              <a:rPr sz="950" b="1" i="0">
                 <a:solidFill>
                   <a:srgbClr val="1A212E"/>
                 </a:solidFill>
@@ -12375,7 +12535,7 @@
               </a:lnSpc>
             </a:pPr>
             <a:r>
-              <a:rPr sz="1150" b="1" i="0">
+              <a:rPr sz="1050" b="1" i="0">
                 <a:solidFill>
                   <a:srgbClr val="D19830"/>
                 </a:solidFill>
@@ -12415,7 +12575,7 @@
               </a:lnSpc>
             </a:pPr>
             <a:r>
-              <a:rPr sz="1100" b="1" i="0">
+              <a:rPr sz="950" b="1" i="0">
                 <a:solidFill>
                   <a:srgbClr val="1A212E"/>
                 </a:solidFill>
@@ -12587,7 +12747,7 @@
               </a:lnSpc>
             </a:pPr>
             <a:r>
-              <a:rPr sz="1150" b="1" i="0">
+              <a:rPr sz="1050" b="1" i="0">
                 <a:solidFill>
                   <a:srgbClr val="8E3542"/>
                 </a:solidFill>
@@ -12627,7 +12787,7 @@
               </a:lnSpc>
             </a:pPr>
             <a:r>
-              <a:rPr sz="1100" b="1" i="0">
+              <a:rPr sz="950" b="1" i="0">
                 <a:solidFill>
                   <a:srgbClr val="1A212E"/>
                 </a:solidFill>
@@ -12799,7 +12959,7 @@
               </a:lnSpc>
             </a:pPr>
             <a:r>
-              <a:rPr sz="1150" b="1" i="0">
+              <a:rPr sz="1050" b="1" i="0">
                 <a:solidFill>
                   <a:srgbClr val="1A212E"/>
                 </a:solidFill>
@@ -12839,7 +12999,7 @@
               </a:lnSpc>
             </a:pPr>
             <a:r>
-              <a:rPr sz="1100" b="1" i="0">
+              <a:rPr sz="950" b="1" i="0">
                 <a:solidFill>
                   <a:srgbClr val="1A212E"/>
                 </a:solidFill>
@@ -12919,14 +13079,134 @@
       <p:grpSpPr/>
       <p:sp>
         <p:nvSpPr>
-          <p:cNvPr id="2" name="Rectangle 1"/>
+          <p:cNvPr id="2" name="TextBox 1"/>
+          <p:cNvSpPr txBox="1"/>
+          <p:nvPr/>
+        </p:nvSpPr>
+        <p:spPr>
+          <a:xfrm>
+            <a:off x="768096" y="329184"/>
+            <a:ext cx="10789920" cy="219760"/>
+          </a:xfrm>
+          <a:prstGeom prst="rect">
+            <a:avLst/>
+          </a:prstGeom>
+          <a:noFill/>
+        </p:spPr>
+        <p:txBody>
+          <a:bodyPr wrap="square" anchor="t" lIns="18288" rIns="18288" tIns="12801" bIns="12801">
+            <a:spAutoFit/>
+          </a:bodyPr>
+          <a:lstStyle/>
+          <a:p>
+            <a:pPr algn="l">
+              <a:lnSpc>
+                <a:spcPct val="125000"/>
+              </a:lnSpc>
+            </a:pPr>
+            <a:r>
+              <a:rPr sz="800" b="1" i="0">
+                <a:solidFill>
+                  <a:srgbClr val="C6532D"/>
+                </a:solidFill>
+                <a:latin typeface="Noto Sans CJK KR"/>
+                <a:ea typeface="Noto Sans CJK KR"/>
+              </a:rPr>
+              <a:t>05  |  SCENE &amp; SEQUEL DYNAMICS</a:t>
+            </a:r>
+          </a:p>
+        </p:txBody>
+      </p:sp>
+      <p:sp>
+        <p:nvSpPr>
+          <p:cNvPr id="3" name="TextBox 2"/>
+          <p:cNvSpPr txBox="1"/>
+          <p:nvPr/>
+        </p:nvSpPr>
+        <p:spPr>
+          <a:xfrm>
+            <a:off x="768096" y="631240"/>
+            <a:ext cx="10789920" cy="423164"/>
+          </a:xfrm>
+          <a:prstGeom prst="rect">
+            <a:avLst/>
+          </a:prstGeom>
+          <a:noFill/>
+        </p:spPr>
+        <p:txBody>
+          <a:bodyPr wrap="square" anchor="t" lIns="18288" rIns="18288" tIns="12801" bIns="12801">
+            <a:spAutoFit/>
+          </a:bodyPr>
+          <a:lstStyle/>
+          <a:p>
+            <a:pPr algn="l">
+              <a:lnSpc>
+                <a:spcPct val="125000"/>
+              </a:lnSpc>
+            </a:pPr>
+            <a:r>
+              <a:rPr sz="1700" b="1" i="0">
+                <a:solidFill>
+                  <a:srgbClr val="1A212E"/>
+                </a:solidFill>
+                <a:latin typeface="Noto Sans CJK KR"/>
+                <a:ea typeface="Noto Sans CJK KR"/>
+              </a:rPr>
+              <a:t>모든 장면(Scene)은 목표·충돌·전환으로 전진하고 반추(Sequel)로 호흡을 조절한다</a:t>
+            </a:r>
+          </a:p>
+        </p:txBody>
+      </p:sp>
+      <p:sp>
+        <p:nvSpPr>
+          <p:cNvPr id="4" name="TextBox 3"/>
+          <p:cNvSpPr txBox="1"/>
+          <p:nvPr/>
+        </p:nvSpPr>
+        <p:spPr>
+          <a:xfrm>
+            <a:off x="768096" y="1136700"/>
+            <a:ext cx="10789920" cy="247497"/>
+          </a:xfrm>
+          <a:prstGeom prst="rect">
+            <a:avLst/>
+          </a:prstGeom>
+          <a:noFill/>
+        </p:spPr>
+        <p:txBody>
+          <a:bodyPr wrap="square" anchor="t" lIns="18288" rIns="18288" tIns="12801" bIns="12801">
+            <a:spAutoFit/>
+          </a:bodyPr>
+          <a:lstStyle/>
+          <a:p>
+            <a:pPr algn="l">
+              <a:lnSpc>
+                <a:spcPct val="125000"/>
+              </a:lnSpc>
+            </a:pPr>
+            <a:r>
+              <a:rPr sz="950" b="0" i="0">
+                <a:solidFill>
+                  <a:srgbClr val="555E6C"/>
+                </a:solidFill>
+                <a:latin typeface="Noto Sans CJK KR"/>
+                <a:ea typeface="Noto Sans CJK KR"/>
+              </a:rPr>
+              <a:t>외면적 사건의 속도감(Scene)과 내면적 감정 소화(Sequel)를 교차 배치해 독자의 피로도를 막고 몰입을 깊게 만든다</a:t>
+            </a:r>
+          </a:p>
+        </p:txBody>
+      </p:sp>
+      <p:sp>
+        <p:nvSpPr>
+          <p:cNvPr id="5" name="Rectangle 4"/>
           <p:cNvSpPr/>
           <p:nvPr/>
         </p:nvSpPr>
         <p:spPr>
           <a:xfrm>
             <a:off x="594360" y="384048"/>
-            <a:ext cx="73152" cy="713232"/>
+            <a:ext cx="73152" cy="917854"/>
           </a:xfrm>
           <a:prstGeom prst="rect">
             <a:avLst/>
@@ -12963,133 +13243,13 @@
       </p:sp>
       <p:sp>
         <p:nvSpPr>
-          <p:cNvPr id="3" name="TextBox 2"/>
-          <p:cNvSpPr txBox="1"/>
-          <p:nvPr/>
-        </p:nvSpPr>
-        <p:spPr>
-          <a:xfrm>
-            <a:off x="768096" y="329184"/>
-            <a:ext cx="8229600" cy="256032"/>
-          </a:xfrm>
-          <a:prstGeom prst="rect">
-            <a:avLst/>
-          </a:prstGeom>
-          <a:noFill/>
-        </p:spPr>
-        <p:txBody>
-          <a:bodyPr wrap="square" anchor="t" lIns="18288" rIns="18288" tIns="12801" bIns="12801">
-            <a:spAutoFit/>
-          </a:bodyPr>
-          <a:lstStyle/>
-          <a:p>
-            <a:pPr algn="l">
-              <a:lnSpc>
-                <a:spcPct val="125000"/>
-              </a:lnSpc>
-            </a:pPr>
-            <a:r>
-              <a:rPr sz="1050" b="1" i="0">
-                <a:solidFill>
-                  <a:srgbClr val="C6532D"/>
-                </a:solidFill>
-                <a:latin typeface="Noto Sans CJK KR"/>
-                <a:ea typeface="Noto Sans CJK KR"/>
-              </a:rPr>
-              <a:t>05  |  SCENE &amp; SEQUEL DYNAMICS</a:t>
-            </a:r>
-          </a:p>
-        </p:txBody>
-      </p:sp>
-      <p:sp>
-        <p:nvSpPr>
-          <p:cNvPr id="4" name="TextBox 3"/>
-          <p:cNvSpPr txBox="1"/>
-          <p:nvPr/>
-        </p:nvSpPr>
-        <p:spPr>
-          <a:xfrm>
-            <a:off x="768096" y="548640"/>
-            <a:ext cx="10789920" cy="402336"/>
-          </a:xfrm>
-          <a:prstGeom prst="rect">
-            <a:avLst/>
-          </a:prstGeom>
-          <a:noFill/>
-        </p:spPr>
-        <p:txBody>
-          <a:bodyPr wrap="square" anchor="t" lIns="18288" rIns="18288" tIns="12801" bIns="12801">
-            <a:spAutoFit/>
-          </a:bodyPr>
-          <a:lstStyle/>
-          <a:p>
-            <a:pPr algn="l">
-              <a:lnSpc>
-                <a:spcPct val="125000"/>
-              </a:lnSpc>
-            </a:pPr>
-            <a:r>
-              <a:rPr sz="2150" b="1" i="0">
-                <a:solidFill>
-                  <a:srgbClr val="1A212E"/>
-                </a:solidFill>
-                <a:latin typeface="Noto Sans CJK KR"/>
-                <a:ea typeface="Noto Sans CJK KR"/>
-              </a:rPr>
-              <a:t>모든 장면(Scene)은 목표·충돌·전환으로 전진하고 반추(Sequel)로 호흡을 조절한다</a:t>
-            </a:r>
-          </a:p>
-        </p:txBody>
-      </p:sp>
-      <p:sp>
-        <p:nvSpPr>
-          <p:cNvPr id="5" name="TextBox 4"/>
-          <p:cNvSpPr txBox="1"/>
-          <p:nvPr/>
-        </p:nvSpPr>
-        <p:spPr>
-          <a:xfrm>
-            <a:off x="768096" y="923544"/>
-            <a:ext cx="10789920" cy="292608"/>
-          </a:xfrm>
-          <a:prstGeom prst="rect">
-            <a:avLst/>
-          </a:prstGeom>
-          <a:noFill/>
-        </p:spPr>
-        <p:txBody>
-          <a:bodyPr wrap="square" anchor="t" lIns="18288" rIns="18288" tIns="12801" bIns="12801">
-            <a:spAutoFit/>
-          </a:bodyPr>
-          <a:lstStyle/>
-          <a:p>
-            <a:pPr algn="l">
-              <a:lnSpc>
-                <a:spcPct val="125000"/>
-              </a:lnSpc>
-            </a:pPr>
-            <a:r>
-              <a:rPr sz="1200" b="0" i="0">
-                <a:solidFill>
-                  <a:srgbClr val="555E6C"/>
-                </a:solidFill>
-                <a:latin typeface="Noto Sans CJK KR"/>
-                <a:ea typeface="Noto Sans CJK KR"/>
-              </a:rPr>
-              <a:t>외면적 사건의 속도감(Scene)과 내면적 감정 소화(Sequel)를 교차 배치해 독자의 피로도를 막고 몰입을 깊게 만든다</a:t>
-            </a:r>
-          </a:p>
-        </p:txBody>
-      </p:sp>
-      <p:sp>
-        <p:nvSpPr>
           <p:cNvPr id="6" name="Rectangle 5"/>
           <p:cNvSpPr/>
           <p:nvPr/>
         </p:nvSpPr>
         <p:spPr>
           <a:xfrm>
-            <a:off x="594360" y="1261872"/>
+            <a:off x="594360" y="1457350"/>
             <a:ext cx="11000232" cy="13716"/>
           </a:xfrm>
           <a:prstGeom prst="rect">
@@ -13325,7 +13485,7 @@
               </a:lnSpc>
             </a:pPr>
             <a:r>
-              <a:rPr sz="1350" b="1" i="0">
+              <a:rPr sz="1250" b="1" i="0">
                 <a:solidFill>
                   <a:srgbClr val="1A212E"/>
                 </a:solidFill>
@@ -13413,7 +13573,7 @@
               </a:lnSpc>
             </a:pPr>
             <a:r>
-              <a:rPr sz="1180" b="1" i="0">
+              <a:rPr sz="1130" b="1" i="0">
                 <a:solidFill>
                   <a:srgbClr val="C6532D"/>
                 </a:solidFill>
@@ -13885,7 +14045,7 @@
               </a:lnSpc>
             </a:pPr>
             <a:r>
-              <a:rPr sz="1180" b="1" i="0">
+              <a:rPr sz="1130" b="1" i="0">
                 <a:solidFill>
                   <a:srgbClr val="316B69"/>
                 </a:solidFill>
@@ -14357,7 +14517,7 @@
               </a:lnSpc>
             </a:pPr>
             <a:r>
-              <a:rPr sz="1300" b="1" i="0">
+              <a:rPr sz="1200" b="1" i="0">
                 <a:solidFill>
                   <a:srgbClr val="1A212E"/>
                 </a:solidFill>
@@ -14489,7 +14649,7 @@
               </a:lnSpc>
             </a:pPr>
             <a:r>
-              <a:rPr sz="1120" b="1" i="0">
+              <a:rPr sz="869" b="1" i="0">
                 <a:solidFill>
                   <a:srgbClr val="C6532D"/>
                 </a:solidFill>
@@ -14661,7 +14821,7 @@
               </a:lnSpc>
             </a:pPr>
             <a:r>
-              <a:rPr sz="1120" b="1" i="0">
+              <a:rPr sz="869" b="1" i="0">
                 <a:solidFill>
                   <a:srgbClr val="316B69"/>
                 </a:solidFill>
@@ -14833,7 +14993,7 @@
               </a:lnSpc>
             </a:pPr>
             <a:r>
-              <a:rPr sz="1120" b="1" i="0">
+              <a:rPr sz="869" b="1" i="0">
                 <a:solidFill>
                   <a:srgbClr val="D19830"/>
                 </a:solidFill>
@@ -14959,7 +15119,7 @@
               </a:lnSpc>
             </a:pPr>
             <a:r>
-              <a:rPr sz="1200" b="1" i="0">
+              <a:rPr sz="1050" b="1" i="0">
                 <a:solidFill>
                   <a:srgbClr val="D19830"/>
                 </a:solidFill>
@@ -15006,9 +15166,29 @@
                 <a:latin typeface="Noto Sans CJK KR"/>
                 <a:ea typeface="Noto Sans CJK KR"/>
               </a:rPr>
-              <a:t>• 장면의 시작과 끝 사이에 인물의 상황·감정의 부호(+/-)가 바뀌었는가?
-• 플롯을 전진시키거나 인물의 핵심 본성을 드러내는가?
-→ 둘 다 아니라면 아무리 문장이 아름다워도 과감히 삭제하라.</a:t>
+              <a:t>• 장면의 시작과 끝 사이에 인물의 상황·감정의 부호(+/-)가 바뀌었는가?</a:t>
+            </a:r>
+            <a:br/>
+            <a:r>
+              <a:rPr sz="1000" b="0" i="0">
+                <a:solidFill>
+                  <a:srgbClr val="F2EFE9"/>
+                </a:solidFill>
+                <a:latin typeface="Noto Sans CJK KR"/>
+                <a:ea typeface="Noto Sans CJK KR"/>
+              </a:rPr>
+              <a:t>• 플롯을 전진시키거나 인물의 핵심 본성을 드러내는가?</a:t>
+            </a:r>
+            <a:br/>
+            <a:r>
+              <a:rPr sz="1000" b="0" i="0">
+                <a:solidFill>
+                  <a:srgbClr val="F2EFE9"/>
+                </a:solidFill>
+                <a:latin typeface="Noto Sans CJK KR"/>
+                <a:ea typeface="Noto Sans CJK KR"/>
+              </a:rPr>
+              <a:t>→ 둘 다 아니라면 아무리 문장이 아름다워도 과감히 삭제하라.</a:t>
             </a:r>
           </a:p>
         </p:txBody>
@@ -15041,14 +15221,134 @@
       <p:grpSpPr/>
       <p:sp>
         <p:nvSpPr>
-          <p:cNvPr id="2" name="Rectangle 1"/>
+          <p:cNvPr id="2" name="TextBox 1"/>
+          <p:cNvSpPr txBox="1"/>
+          <p:nvPr/>
+        </p:nvSpPr>
+        <p:spPr>
+          <a:xfrm>
+            <a:off x="768096" y="329184"/>
+            <a:ext cx="10789920" cy="219760"/>
+          </a:xfrm>
+          <a:prstGeom prst="rect">
+            <a:avLst/>
+          </a:prstGeom>
+          <a:noFill/>
+        </p:spPr>
+        <p:txBody>
+          <a:bodyPr wrap="square" anchor="t" lIns="18288" rIns="18288" tIns="12801" bIns="12801">
+            <a:spAutoFit/>
+          </a:bodyPr>
+          <a:lstStyle/>
+          <a:p>
+            <a:pPr algn="l">
+              <a:lnSpc>
+                <a:spcPct val="125000"/>
+              </a:lnSpc>
+            </a:pPr>
+            <a:r>
+              <a:rPr sz="800" b="1" i="0">
+                <a:solidFill>
+                  <a:srgbClr val="C6532D"/>
+                </a:solidFill>
+                <a:latin typeface="Noto Sans CJK KR"/>
+                <a:ea typeface="Noto Sans CJK KR"/>
+              </a:rPr>
+              <a:t>06  |  POINT OF VIEW (POV) &amp; NARRATIVE DISTANCE</a:t>
+            </a:r>
+          </a:p>
+        </p:txBody>
+      </p:sp>
+      <p:sp>
+        <p:nvSpPr>
+          <p:cNvPr id="3" name="TextBox 2"/>
+          <p:cNvSpPr txBox="1"/>
+          <p:nvPr/>
+        </p:nvSpPr>
+        <p:spPr>
+          <a:xfrm>
+            <a:off x="768096" y="631240"/>
+            <a:ext cx="10789920" cy="423164"/>
+          </a:xfrm>
+          <a:prstGeom prst="rect">
+            <a:avLst/>
+          </a:prstGeom>
+          <a:noFill/>
+        </p:spPr>
+        <p:txBody>
+          <a:bodyPr wrap="square" anchor="t" lIns="18288" rIns="18288" tIns="12801" bIns="12801">
+            <a:spAutoFit/>
+          </a:bodyPr>
+          <a:lstStyle/>
+          <a:p>
+            <a:pPr algn="l">
+              <a:lnSpc>
+                <a:spcPct val="125000"/>
+              </a:lnSpc>
+            </a:pPr>
+            <a:r>
+              <a:rPr sz="1700" b="1" i="0">
+                <a:solidFill>
+                  <a:srgbClr val="1A212E"/>
+                </a:solidFill>
+                <a:latin typeface="Noto Sans CJK KR"/>
+                <a:ea typeface="Noto Sans CJK KR"/>
+              </a:rPr>
+              <a:t>누구의 눈으로 어디까지 보여줄 것인가: 시점(POV)이 소설의 몰입도를 결정한다</a:t>
+            </a:r>
+          </a:p>
+        </p:txBody>
+      </p:sp>
+      <p:sp>
+        <p:nvSpPr>
+          <p:cNvPr id="4" name="TextBox 3"/>
+          <p:cNvSpPr txBox="1"/>
+          <p:nvPr/>
+        </p:nvSpPr>
+        <p:spPr>
+          <a:xfrm>
+            <a:off x="768096" y="1136700"/>
+            <a:ext cx="10789920" cy="247497"/>
+          </a:xfrm>
+          <a:prstGeom prst="rect">
+            <a:avLst/>
+          </a:prstGeom>
+          <a:noFill/>
+        </p:spPr>
+        <p:txBody>
+          <a:bodyPr wrap="square" anchor="t" lIns="18288" rIns="18288" tIns="12801" bIns="12801">
+            <a:spAutoFit/>
+          </a:bodyPr>
+          <a:lstStyle/>
+          <a:p>
+            <a:pPr algn="l">
+              <a:lnSpc>
+                <a:spcPct val="125000"/>
+              </a:lnSpc>
+            </a:pPr>
+            <a:r>
+              <a:rPr sz="950" b="0" i="0">
+                <a:solidFill>
+                  <a:srgbClr val="555E6C"/>
+                </a:solidFill>
+                <a:latin typeface="Noto Sans CJK KR"/>
+                <a:ea typeface="Noto Sans CJK KR"/>
+              </a:rPr>
+              <a:t>각 시점의 정보 통제 범위와 심리적 거리를 이해하고, 한 장면 안에서는 단일 시점을 엄격히 유지하라</a:t>
+            </a:r>
+          </a:p>
+        </p:txBody>
+      </p:sp>
+      <p:sp>
+        <p:nvSpPr>
+          <p:cNvPr id="5" name="Rectangle 4"/>
           <p:cNvSpPr/>
           <p:nvPr/>
         </p:nvSpPr>
         <p:spPr>
           <a:xfrm>
             <a:off x="594360" y="384048"/>
-            <a:ext cx="73152" cy="713232"/>
+            <a:ext cx="73152" cy="917854"/>
           </a:xfrm>
           <a:prstGeom prst="rect">
             <a:avLst/>
@@ -15085,133 +15385,13 @@
       </p:sp>
       <p:sp>
         <p:nvSpPr>
-          <p:cNvPr id="3" name="TextBox 2"/>
-          <p:cNvSpPr txBox="1"/>
-          <p:nvPr/>
-        </p:nvSpPr>
-        <p:spPr>
-          <a:xfrm>
-            <a:off x="768096" y="329184"/>
-            <a:ext cx="8229600" cy="256032"/>
-          </a:xfrm>
-          <a:prstGeom prst="rect">
-            <a:avLst/>
-          </a:prstGeom>
-          <a:noFill/>
-        </p:spPr>
-        <p:txBody>
-          <a:bodyPr wrap="square" anchor="t" lIns="18288" rIns="18288" tIns="12801" bIns="12801">
-            <a:spAutoFit/>
-          </a:bodyPr>
-          <a:lstStyle/>
-          <a:p>
-            <a:pPr algn="l">
-              <a:lnSpc>
-                <a:spcPct val="125000"/>
-              </a:lnSpc>
-            </a:pPr>
-            <a:r>
-              <a:rPr sz="1050" b="1" i="0">
-                <a:solidFill>
-                  <a:srgbClr val="C6532D"/>
-                </a:solidFill>
-                <a:latin typeface="Noto Sans CJK KR"/>
-                <a:ea typeface="Noto Sans CJK KR"/>
-              </a:rPr>
-              <a:t>06  |  POINT OF VIEW (POV) &amp; NARRATIVE DISTANCE</a:t>
-            </a:r>
-          </a:p>
-        </p:txBody>
-      </p:sp>
-      <p:sp>
-        <p:nvSpPr>
-          <p:cNvPr id="4" name="TextBox 3"/>
-          <p:cNvSpPr txBox="1"/>
-          <p:nvPr/>
-        </p:nvSpPr>
-        <p:spPr>
-          <a:xfrm>
-            <a:off x="768096" y="548640"/>
-            <a:ext cx="10789920" cy="402336"/>
-          </a:xfrm>
-          <a:prstGeom prst="rect">
-            <a:avLst/>
-          </a:prstGeom>
-          <a:noFill/>
-        </p:spPr>
-        <p:txBody>
-          <a:bodyPr wrap="square" anchor="t" lIns="18288" rIns="18288" tIns="12801" bIns="12801">
-            <a:spAutoFit/>
-          </a:bodyPr>
-          <a:lstStyle/>
-          <a:p>
-            <a:pPr algn="l">
-              <a:lnSpc>
-                <a:spcPct val="125000"/>
-              </a:lnSpc>
-            </a:pPr>
-            <a:r>
-              <a:rPr sz="2150" b="1" i="0">
-                <a:solidFill>
-                  <a:srgbClr val="1A212E"/>
-                </a:solidFill>
-                <a:latin typeface="Noto Sans CJK KR"/>
-                <a:ea typeface="Noto Sans CJK KR"/>
-              </a:rPr>
-              <a:t>누구의 눈으로 어디까지 보여줄 것인가: 시점(POV)이 소설의 몰입도를 결정한다</a:t>
-            </a:r>
-          </a:p>
-        </p:txBody>
-      </p:sp>
-      <p:sp>
-        <p:nvSpPr>
-          <p:cNvPr id="5" name="TextBox 4"/>
-          <p:cNvSpPr txBox="1"/>
-          <p:nvPr/>
-        </p:nvSpPr>
-        <p:spPr>
-          <a:xfrm>
-            <a:off x="768096" y="923544"/>
-            <a:ext cx="10789920" cy="292608"/>
-          </a:xfrm>
-          <a:prstGeom prst="rect">
-            <a:avLst/>
-          </a:prstGeom>
-          <a:noFill/>
-        </p:spPr>
-        <p:txBody>
-          <a:bodyPr wrap="square" anchor="t" lIns="18288" rIns="18288" tIns="12801" bIns="12801">
-            <a:spAutoFit/>
-          </a:bodyPr>
-          <a:lstStyle/>
-          <a:p>
-            <a:pPr algn="l">
-              <a:lnSpc>
-                <a:spcPct val="125000"/>
-              </a:lnSpc>
-            </a:pPr>
-            <a:r>
-              <a:rPr sz="1200" b="0" i="0">
-                <a:solidFill>
-                  <a:srgbClr val="555E6C"/>
-                </a:solidFill>
-                <a:latin typeface="Noto Sans CJK KR"/>
-                <a:ea typeface="Noto Sans CJK KR"/>
-              </a:rPr>
-              <a:t>각 시점의 정보 통제 범위와 심리적 거리를 이해하고, 한 장면 안에서는 단일 시점을 엄격히 유지하라</a:t>
-            </a:r>
-          </a:p>
-        </p:txBody>
-      </p:sp>
-      <p:sp>
-        <p:nvSpPr>
           <p:cNvPr id="6" name="Rectangle 5"/>
           <p:cNvSpPr/>
           <p:nvPr/>
         </p:nvSpPr>
         <p:spPr>
           <a:xfrm>
-            <a:off x="594360" y="1261872"/>
+            <a:off x="594360" y="1457350"/>
             <a:ext cx="11000232" cy="13716"/>
           </a:xfrm>
           <a:prstGeom prst="rect">
@@ -15882,8 +16062,18 @@
                 <a:latin typeface="Noto Sans CJK KR"/>
                 <a:ea typeface="Noto Sans CJK KR"/>
               </a:rPr>
-              <a:t>1인칭 주인공 시점
-(‘나’의 서술)</a:t>
+              <a:t>1인칭 주인공 시점</a:t>
+            </a:r>
+            <a:br/>
+            <a:r>
+              <a:rPr sz="1050" b="1" i="0">
+                <a:solidFill>
+                  <a:srgbClr val="1A212E"/>
+                </a:solidFill>
+                <a:latin typeface="Noto Sans CJK KR"/>
+                <a:ea typeface="Noto Sans CJK KR"/>
+              </a:rPr>
+              <a:t>(‘나’의 서술)</a:t>
             </a:r>
           </a:p>
         </p:txBody>
@@ -16055,9 +16245,29 @@
                 <a:latin typeface="Noto Sans CJK KR"/>
                 <a:ea typeface="Noto Sans CJK KR"/>
               </a:rPr>
-              <a:t>• 독자와 주인공의 즉각적 밀착
-• 화자의 독특한 목소리·유머 극대화
-• ‘신뢰할 수 없는 화자’ 트릭에 유리</a:t>
+              <a:t>• 독자와 주인공의 즉각적 밀착</a:t>
+            </a:r>
+            <a:br/>
+            <a:r>
+              <a:rPr sz="990" b="0" i="0">
+                <a:solidFill>
+                  <a:srgbClr val="555E6C"/>
+                </a:solidFill>
+                <a:latin typeface="Noto Sans CJK KR"/>
+                <a:ea typeface="Noto Sans CJK KR"/>
+              </a:rPr>
+              <a:t>• 화자의 독특한 목소리·유머 극대화</a:t>
+            </a:r>
+            <a:br/>
+            <a:r>
+              <a:rPr sz="990" b="0" i="0">
+                <a:solidFill>
+                  <a:srgbClr val="555E6C"/>
+                </a:solidFill>
+                <a:latin typeface="Noto Sans CJK KR"/>
+                <a:ea typeface="Noto Sans CJK KR"/>
+              </a:rPr>
+              <a:t>• ‘신뢰할 수 없는 화자’ 트릭에 유리</a:t>
             </a:r>
           </a:p>
         </p:txBody>
@@ -16143,8 +16353,18 @@
                 <a:latin typeface="Noto Sans CJK KR"/>
                 <a:ea typeface="Noto Sans CJK KR"/>
               </a:rPr>
-              <a:t>• 주인공이 없는 현장의 사건 서술 불가
-• 지나친 자기연민이나 독백 과잉 위험</a:t>
+              <a:t>• 주인공이 없는 현장의 사건 서술 불가</a:t>
+            </a:r>
+            <a:br/>
+            <a:r>
+              <a:rPr sz="990" b="0" i="0">
+                <a:solidFill>
+                  <a:srgbClr val="555E6C"/>
+                </a:solidFill>
+                <a:latin typeface="Noto Sans CJK KR"/>
+                <a:ea typeface="Noto Sans CJK KR"/>
+              </a:rPr>
+              <a:t>• 지나친 자기연민이나 독백 과잉 위험</a:t>
             </a:r>
           </a:p>
         </p:txBody>
@@ -16230,8 +16450,18 @@
                 <a:latin typeface="Noto Sans CJK KR"/>
                 <a:ea typeface="Noto Sans CJK KR"/>
               </a:rPr>
-              <a:t>청춘 성장소설, 느와르,
-심리 미스터리, 고백록</a:t>
+              <a:t>청춘 성장소설, 느와르,</a:t>
+            </a:r>
+            <a:br/>
+            <a:r>
+              <a:rPr sz="990" b="0" i="0">
+                <a:solidFill>
+                  <a:srgbClr val="555E6C"/>
+                </a:solidFill>
+                <a:latin typeface="Noto Sans CJK KR"/>
+                <a:ea typeface="Noto Sans CJK KR"/>
+              </a:rPr>
+              <a:t>심리 미스터리, 고백록</a:t>
             </a:r>
           </a:p>
         </p:txBody>
@@ -16317,8 +16547,18 @@
                 <a:latin typeface="Noto Sans CJK KR"/>
                 <a:ea typeface="Noto Sans CJK KR"/>
               </a:rPr>
-              <a:t>3인칭 제한 시점
-(현대 소설의 표준)</a:t>
+              <a:t>3인칭 제한 시점</a:t>
+            </a:r>
+            <a:br/>
+            <a:r>
+              <a:rPr sz="1050" b="1" i="0">
+                <a:solidFill>
+                  <a:srgbClr val="C6532D"/>
+                </a:solidFill>
+                <a:latin typeface="Noto Sans CJK KR"/>
+                <a:ea typeface="Noto Sans CJK KR"/>
+              </a:rPr>
+              <a:t>(현대 소설의 표준)</a:t>
             </a:r>
           </a:p>
         </p:txBody>
@@ -16490,8 +16730,18 @@
                 <a:latin typeface="Noto Sans CJK KR"/>
                 <a:ea typeface="Noto Sans CJK KR"/>
               </a:rPr>
-              <a:t>• 1인칭의 깊은 정서적 몰입감과 3인칭의 객관적 묘사력을 동시에 확보
-• 서사적 거리를 유연하게 줌인/줌아웃</a:t>
+              <a:t>• 1인칭의 깊은 정서적 몰입감과 3인칭의 객관적 묘사력을 동시에 확보</a:t>
+            </a:r>
+            <a:br/>
+            <a:r>
+              <a:rPr sz="990" b="0" i="0">
+                <a:solidFill>
+                  <a:srgbClr val="555E6C"/>
+                </a:solidFill>
+                <a:latin typeface="Noto Sans CJK KR"/>
+                <a:ea typeface="Noto Sans CJK KR"/>
+              </a:rPr>
+              <a:t>• 서사적 거리를 유연하게 줌인/줌아웃</a:t>
             </a:r>
           </a:p>
         </p:txBody>
@@ -16663,8 +16913,18 @@
                 <a:latin typeface="Noto Sans CJK KR"/>
                 <a:ea typeface="Noto Sans CJK KR"/>
               </a:rPr>
-              <a:t>현대 문학 전반, 장르소설,
-장편 드라마의 가장 안정적 선택</a:t>
+              <a:t>현대 문학 전반, 장르소설,</a:t>
+            </a:r>
+            <a:br/>
+            <a:r>
+              <a:rPr sz="990" b="0" i="0">
+                <a:solidFill>
+                  <a:srgbClr val="555E6C"/>
+                </a:solidFill>
+                <a:latin typeface="Noto Sans CJK KR"/>
+                <a:ea typeface="Noto Sans CJK KR"/>
+              </a:rPr>
+              <a:t>장편 드라마의 가장 안정적 선택</a:t>
             </a:r>
           </a:p>
         </p:txBody>
@@ -16750,8 +17010,18 @@
                 <a:latin typeface="Noto Sans CJK KR"/>
                 <a:ea typeface="Noto Sans CJK KR"/>
               </a:rPr>
-              <a:t>3인칭 전지적 시점
-(신적 조망)</a:t>
+              <a:t>3인칭 전지적 시점</a:t>
+            </a:r>
+            <a:br/>
+            <a:r>
+              <a:rPr sz="1050" b="1" i="0">
+                <a:solidFill>
+                  <a:srgbClr val="1A212E"/>
+                </a:solidFill>
+                <a:latin typeface="Noto Sans CJK KR"/>
+                <a:ea typeface="Noto Sans CJK KR"/>
+              </a:rPr>
+              <a:t>(신적 조망)</a:t>
             </a:r>
           </a:p>
         </p:txBody>
@@ -16923,8 +17193,18 @@
                 <a:latin typeface="Noto Sans CJK KR"/>
                 <a:ea typeface="Noto Sans CJK KR"/>
               </a:rPr>
-              <a:t>• 방대한 세계관과 시대상을 조망
-• 인물 간의 오해와 극적 아이러니를 독자에게 입체적으로 제시</a:t>
+              <a:t>• 방대한 세계관과 시대상을 조망</a:t>
+            </a:r>
+            <a:br/>
+            <a:r>
+              <a:rPr sz="990" b="0" i="0">
+                <a:solidFill>
+                  <a:srgbClr val="555E6C"/>
+                </a:solidFill>
+                <a:latin typeface="Noto Sans CJK KR"/>
+                <a:ea typeface="Noto Sans CJK KR"/>
+              </a:rPr>
+              <a:t>• 인물 간의 오해와 극적 아이러니를 독자에게 입체적으로 제시</a:t>
             </a:r>
           </a:p>
         </p:txBody>
@@ -17096,8 +17376,18 @@
                 <a:latin typeface="Noto Sans CJK KR"/>
                 <a:ea typeface="Noto Sans CJK KR"/>
               </a:rPr>
-              <a:t>대하 역사소설, 가족 사가(Saga),
-우화적·철학적 서사</a:t>
+              <a:t>대하 역사소설, 가족 사가(Saga),</a:t>
+            </a:r>
+            <a:br/>
+            <a:r>
+              <a:rPr sz="990" b="0" i="0">
+                <a:solidFill>
+                  <a:srgbClr val="555E6C"/>
+                </a:solidFill>
+                <a:latin typeface="Noto Sans CJK KR"/>
+                <a:ea typeface="Noto Sans CJK KR"/>
+              </a:rPr>
+              <a:t>우화적·철학적 서사</a:t>
             </a:r>
           </a:p>
         </p:txBody>
@@ -17183,8 +17473,18 @@
                 <a:latin typeface="Noto Sans CJK KR"/>
                 <a:ea typeface="Noto Sans CJK KR"/>
               </a:rPr>
-              <a:t>다중 교차 시점
-(챕터별 3인칭/1인칭)</a:t>
+              <a:t>다중 교차 시점</a:t>
+            </a:r>
+            <a:br/>
+            <a:r>
+              <a:rPr sz="1050" b="1" i="0">
+                <a:solidFill>
+                  <a:srgbClr val="1A212E"/>
+                </a:solidFill>
+                <a:latin typeface="Noto Sans CJK KR"/>
+                <a:ea typeface="Noto Sans CJK KR"/>
+              </a:rPr>
+              <a:t>(챕터별 3인칭/1인칭)</a:t>
             </a:r>
           </a:p>
         </p:txBody>
@@ -17356,8 +17656,18 @@
                 <a:latin typeface="Noto Sans CJK KR"/>
                 <a:ea typeface="Noto Sans CJK KR"/>
               </a:rPr>
-              <a:t>• 주인공과 적대자 양측의 정당성 부여
-• 시점 교차 절단신공(Cliffhanger)으로 페이지 터너 효과 극대화</a:t>
+              <a:t>• 주인공과 적대자 양측의 정당성 부여</a:t>
+            </a:r>
+            <a:br/>
+            <a:r>
+              <a:rPr sz="990" b="0" i="0">
+                <a:solidFill>
+                  <a:srgbClr val="555E6C"/>
+                </a:solidFill>
+                <a:latin typeface="Noto Sans CJK KR"/>
+                <a:ea typeface="Noto Sans CJK KR"/>
+              </a:rPr>
+              <a:t>• 시점 교차 절단신공(Cliffhanger)으로 페이지 터너 효과 극대화</a:t>
             </a:r>
           </a:p>
         </p:txBody>
@@ -17436,15 +17746,25 @@
               </a:lnSpc>
             </a:pPr>
             <a:r>
-              <a:rPr sz="990" b="0" i="0">
+              <a:rPr sz="890" b="0" i="0">
                 <a:solidFill>
                   <a:srgbClr val="555E6C"/>
                 </a:solidFill>
                 <a:latin typeface="Noto Sans CJK KR"/>
                 <a:ea typeface="Noto Sans CJK KR"/>
               </a:rPr>
-              <a:t>• 시점 인물 간 목소리가 비슷하면 독자가 화자를 혼동
-• 서사 밀도가 낮은 시점 챕터가 지루해짐</a:t>
+              <a:t>• 시점 인물 간 목소리가 비슷하면 독자가 화자를 혼동</a:t>
+            </a:r>
+            <a:br/>
+            <a:r>
+              <a:rPr sz="890" b="0" i="0">
+                <a:solidFill>
+                  <a:srgbClr val="555E6C"/>
+                </a:solidFill>
+                <a:latin typeface="Noto Sans CJK KR"/>
+                <a:ea typeface="Noto Sans CJK KR"/>
+              </a:rPr>
+              <a:t>• 서사 밀도가 낮은 시점 챕터가 지루해짐</a:t>
             </a:r>
           </a:p>
         </p:txBody>
@@ -17530,8 +17850,18 @@
                 <a:latin typeface="Noto Sans CJK KR"/>
                 <a:ea typeface="Noto Sans CJK KR"/>
               </a:rPr>
-              <a:t>군상극, 범죄 스릴러,
-거대 판타지, 로맨스(쌍방 시점)</a:t>
+              <a:t>군상극, 범죄 스릴러,</a:t>
+            </a:r>
+            <a:br/>
+            <a:r>
+              <a:rPr sz="990" b="0" i="0">
+                <a:solidFill>
+                  <a:srgbClr val="555E6C"/>
+                </a:solidFill>
+                <a:latin typeface="Noto Sans CJK KR"/>
+                <a:ea typeface="Noto Sans CJK KR"/>
+              </a:rPr>
+              <a:t>거대 판타지, 로맨스(쌍방 시점)</a:t>
             </a:r>
           </a:p>
         </p:txBody>
@@ -17652,14 +17982,134 @@
       <p:grpSpPr/>
       <p:sp>
         <p:nvSpPr>
-          <p:cNvPr id="2" name="Rectangle 1"/>
+          <p:cNvPr id="2" name="TextBox 1"/>
+          <p:cNvSpPr txBox="1"/>
+          <p:nvPr/>
+        </p:nvSpPr>
+        <p:spPr>
+          <a:xfrm>
+            <a:off x="768096" y="329184"/>
+            <a:ext cx="10789920" cy="219760"/>
+          </a:xfrm>
+          <a:prstGeom prst="rect">
+            <a:avLst/>
+          </a:prstGeom>
+          <a:noFill/>
+        </p:spPr>
+        <p:txBody>
+          <a:bodyPr wrap="square" anchor="t" lIns="18288" rIns="18288" tIns="12801" bIns="12801">
+            <a:spAutoFit/>
+          </a:bodyPr>
+          <a:lstStyle/>
+          <a:p>
+            <a:pPr algn="l">
+              <a:lnSpc>
+                <a:spcPct val="125000"/>
+              </a:lnSpc>
+            </a:pPr>
+            <a:r>
+              <a:rPr sz="800" b="1" i="0">
+                <a:solidFill>
+                  <a:srgbClr val="C6532D"/>
+                </a:solidFill>
+                <a:latin typeface="Noto Sans CJK KR"/>
+                <a:ea typeface="Noto Sans CJK KR"/>
+              </a:rPr>
+              <a:t>07  |  STYLE &amp; DESCRIPTION CLINIC (SHOW, DON'T TELL)</a:t>
+            </a:r>
+          </a:p>
+        </p:txBody>
+      </p:sp>
+      <p:sp>
+        <p:nvSpPr>
+          <p:cNvPr id="3" name="TextBox 2"/>
+          <p:cNvSpPr txBox="1"/>
+          <p:nvPr/>
+        </p:nvSpPr>
+        <p:spPr>
+          <a:xfrm>
+            <a:off x="768096" y="631240"/>
+            <a:ext cx="10789920" cy="423164"/>
+          </a:xfrm>
+          <a:prstGeom prst="rect">
+            <a:avLst/>
+          </a:prstGeom>
+          <a:noFill/>
+        </p:spPr>
+        <p:txBody>
+          <a:bodyPr wrap="square" anchor="t" lIns="18288" rIns="18288" tIns="12801" bIns="12801">
+            <a:spAutoFit/>
+          </a:bodyPr>
+          <a:lstStyle/>
+          <a:p>
+            <a:pPr algn="l">
+              <a:lnSpc>
+                <a:spcPct val="125000"/>
+              </a:lnSpc>
+            </a:pPr>
+            <a:r>
+              <a:rPr sz="1700" b="1" i="0">
+                <a:solidFill>
+                  <a:srgbClr val="1A212E"/>
+                </a:solidFill>
+                <a:latin typeface="Noto Sans CJK KR"/>
+                <a:ea typeface="Noto Sans CJK KR"/>
+              </a:rPr>
+              <a:t>감정을 단어로 요약(Tell)하지 말고, 오감과 행동의 디테일로 독자가 직접 느끼게 하라(Show)</a:t>
+            </a:r>
+          </a:p>
+        </p:txBody>
+      </p:sp>
+      <p:sp>
+        <p:nvSpPr>
+          <p:cNvPr id="4" name="TextBox 3"/>
+          <p:cNvSpPr txBox="1"/>
+          <p:nvPr/>
+        </p:nvSpPr>
+        <p:spPr>
+          <a:xfrm>
+            <a:off x="768096" y="1136700"/>
+            <a:ext cx="10789920" cy="247497"/>
+          </a:xfrm>
+          <a:prstGeom prst="rect">
+            <a:avLst/>
+          </a:prstGeom>
+          <a:noFill/>
+        </p:spPr>
+        <p:txBody>
+          <a:bodyPr wrap="square" anchor="t" lIns="18288" rIns="18288" tIns="12801" bIns="12801">
+            <a:spAutoFit/>
+          </a:bodyPr>
+          <a:lstStyle/>
+          <a:p>
+            <a:pPr algn="l">
+              <a:lnSpc>
+                <a:spcPct val="125000"/>
+              </a:lnSpc>
+            </a:pPr>
+            <a:r>
+              <a:rPr sz="950" b="0" i="0">
+                <a:solidFill>
+                  <a:srgbClr val="555E6C"/>
+                </a:solidFill>
+                <a:latin typeface="Noto Sans CJK KR"/>
+                <a:ea typeface="Noto Sans CJK KR"/>
+              </a:rPr>
+              <a:t>추상적인 감정어(슬펐다, 화났다, 불안했다)를 지우고 그 감정이 만들어내는 신체 반응과 사물의 이미지로 치환한다</a:t>
+            </a:r>
+          </a:p>
+        </p:txBody>
+      </p:sp>
+      <p:sp>
+        <p:nvSpPr>
+          <p:cNvPr id="5" name="Rectangle 4"/>
           <p:cNvSpPr/>
           <p:nvPr/>
         </p:nvSpPr>
         <p:spPr>
           <a:xfrm>
             <a:off x="594360" y="384048"/>
-            <a:ext cx="73152" cy="713232"/>
+            <a:ext cx="73152" cy="917854"/>
           </a:xfrm>
           <a:prstGeom prst="rect">
             <a:avLst/>
@@ -17696,133 +18146,13 @@
       </p:sp>
       <p:sp>
         <p:nvSpPr>
-          <p:cNvPr id="3" name="TextBox 2"/>
-          <p:cNvSpPr txBox="1"/>
-          <p:nvPr/>
-        </p:nvSpPr>
-        <p:spPr>
-          <a:xfrm>
-            <a:off x="768096" y="329184"/>
-            <a:ext cx="8229600" cy="256032"/>
-          </a:xfrm>
-          <a:prstGeom prst="rect">
-            <a:avLst/>
-          </a:prstGeom>
-          <a:noFill/>
-        </p:spPr>
-        <p:txBody>
-          <a:bodyPr wrap="square" anchor="t" lIns="18288" rIns="18288" tIns="12801" bIns="12801">
-            <a:spAutoFit/>
-          </a:bodyPr>
-          <a:lstStyle/>
-          <a:p>
-            <a:pPr algn="l">
-              <a:lnSpc>
-                <a:spcPct val="125000"/>
-              </a:lnSpc>
-            </a:pPr>
-            <a:r>
-              <a:rPr sz="1050" b="1" i="0">
-                <a:solidFill>
-                  <a:srgbClr val="C6532D"/>
-                </a:solidFill>
-                <a:latin typeface="Noto Sans CJK KR"/>
-                <a:ea typeface="Noto Sans CJK KR"/>
-              </a:rPr>
-              <a:t>07  |  STYLE &amp; DESCRIPTION CLINIC (SHOW, DON'T TELL)</a:t>
-            </a:r>
-          </a:p>
-        </p:txBody>
-      </p:sp>
-      <p:sp>
-        <p:nvSpPr>
-          <p:cNvPr id="4" name="TextBox 3"/>
-          <p:cNvSpPr txBox="1"/>
-          <p:nvPr/>
-        </p:nvSpPr>
-        <p:spPr>
-          <a:xfrm>
-            <a:off x="768096" y="548640"/>
-            <a:ext cx="10789920" cy="402336"/>
-          </a:xfrm>
-          <a:prstGeom prst="rect">
-            <a:avLst/>
-          </a:prstGeom>
-          <a:noFill/>
-        </p:spPr>
-        <p:txBody>
-          <a:bodyPr wrap="square" anchor="t" lIns="18288" rIns="18288" tIns="12801" bIns="12801">
-            <a:spAutoFit/>
-          </a:bodyPr>
-          <a:lstStyle/>
-          <a:p>
-            <a:pPr algn="l">
-              <a:lnSpc>
-                <a:spcPct val="125000"/>
-              </a:lnSpc>
-            </a:pPr>
-            <a:r>
-              <a:rPr sz="2150" b="1" i="0">
-                <a:solidFill>
-                  <a:srgbClr val="1A212E"/>
-                </a:solidFill>
-                <a:latin typeface="Noto Sans CJK KR"/>
-                <a:ea typeface="Noto Sans CJK KR"/>
-              </a:rPr>
-              <a:t>감정을 단어로 요약(Tell)하지 말고, 오감과 행동의 디테일로 독자가 직접 느끼게 하라(Show)</a:t>
-            </a:r>
-          </a:p>
-        </p:txBody>
-      </p:sp>
-      <p:sp>
-        <p:nvSpPr>
-          <p:cNvPr id="5" name="TextBox 4"/>
-          <p:cNvSpPr txBox="1"/>
-          <p:nvPr/>
-        </p:nvSpPr>
-        <p:spPr>
-          <a:xfrm>
-            <a:off x="768096" y="923544"/>
-            <a:ext cx="10789920" cy="292608"/>
-          </a:xfrm>
-          <a:prstGeom prst="rect">
-            <a:avLst/>
-          </a:prstGeom>
-          <a:noFill/>
-        </p:spPr>
-        <p:txBody>
-          <a:bodyPr wrap="square" anchor="t" lIns="18288" rIns="18288" tIns="12801" bIns="12801">
-            <a:spAutoFit/>
-          </a:bodyPr>
-          <a:lstStyle/>
-          <a:p>
-            <a:pPr algn="l">
-              <a:lnSpc>
-                <a:spcPct val="125000"/>
-              </a:lnSpc>
-            </a:pPr>
-            <a:r>
-              <a:rPr sz="1200" b="0" i="0">
-                <a:solidFill>
-                  <a:srgbClr val="555E6C"/>
-                </a:solidFill>
-                <a:latin typeface="Noto Sans CJK KR"/>
-                <a:ea typeface="Noto Sans CJK KR"/>
-              </a:rPr>
-              <a:t>추상적인 감정어(슬펐다, 화났다, 불안했다)를 지우고 그 감정이 만들어내는 신체 반응과 사물의 이미지로 치환한다</a:t>
-            </a:r>
-          </a:p>
-        </p:txBody>
-      </p:sp>
-      <p:sp>
-        <p:nvSpPr>
           <p:cNvPr id="6" name="Rectangle 5"/>
           <p:cNvSpPr/>
           <p:nvPr/>
         </p:nvSpPr>
         <p:spPr>
           <a:xfrm>
-            <a:off x="594360" y="1261872"/>
+            <a:off x="594360" y="1457350"/>
             <a:ext cx="11000232" cy="13716"/>
           </a:xfrm>
           <a:prstGeom prst="rect">
@@ -18058,7 +18388,7 @@
               </a:lnSpc>
             </a:pPr>
             <a:r>
-              <a:rPr sz="950" b="1" i="0">
+              <a:rPr sz="850" b="1" i="0">
                 <a:solidFill>
                   <a:srgbClr val="878E99"/>
                 </a:solidFill>
@@ -18138,7 +18468,7 @@
               </a:lnSpc>
             </a:pPr>
             <a:r>
-              <a:rPr sz="2000" b="1" i="0">
+              <a:rPr sz="1400" b="1" i="0">
                 <a:solidFill>
                   <a:srgbClr val="C6532D"/>
                 </a:solidFill>
@@ -18270,7 +18600,7 @@
               </a:lnSpc>
             </a:pPr>
             <a:r>
-              <a:rPr sz="950" b="1" i="0">
+              <a:rPr sz="850" b="1" i="0">
                 <a:solidFill>
                   <a:srgbClr val="316B69"/>
                 </a:solidFill>
@@ -18291,7 +18621,7 @@
         <p:spPr>
           <a:xfrm>
             <a:off x="8823960" y="1481328"/>
-            <a:ext cx="2633472" cy="219456"/>
+            <a:ext cx="2633472" cy="246888"/>
           </a:xfrm>
           <a:prstGeom prst="roundRect">
             <a:avLst>
@@ -18337,7 +18667,7 @@
         <p:spPr>
           <a:xfrm>
             <a:off x="8823960" y="1481328"/>
-            <a:ext cx="2633472" cy="219456"/>
+            <a:ext cx="2633472" cy="246888"/>
           </a:xfrm>
           <a:prstGeom prst="rect">
             <a:avLst/>
@@ -18352,7 +18682,7 @@
           <a:p>
             <a:pPr algn="ctr">
               <a:lnSpc>
-                <a:spcPct val="125000"/>
+                <a:spcPct val="100000"/>
               </a:lnSpc>
             </a:pPr>
             <a:r>
@@ -18484,7 +18814,7 @@
               </a:lnSpc>
             </a:pPr>
             <a:r>
-              <a:rPr sz="950" b="1" i="0">
+              <a:rPr sz="850" b="1" i="0">
                 <a:solidFill>
                   <a:srgbClr val="878E99"/>
                 </a:solidFill>
@@ -18564,7 +18894,7 @@
               </a:lnSpc>
             </a:pPr>
             <a:r>
-              <a:rPr sz="2000" b="1" i="0">
+              <a:rPr sz="1400" b="1" i="0">
                 <a:solidFill>
                   <a:srgbClr val="C6532D"/>
                 </a:solidFill>
@@ -18696,7 +19026,7 @@
               </a:lnSpc>
             </a:pPr>
             <a:r>
-              <a:rPr sz="950" b="1" i="0">
+              <a:rPr sz="850" b="1" i="0">
                 <a:solidFill>
                   <a:srgbClr val="316B69"/>
                 </a:solidFill>
@@ -18717,7 +19047,7 @@
         <p:spPr>
           <a:xfrm>
             <a:off x="8823960" y="2596896"/>
-            <a:ext cx="2633472" cy="219456"/>
+            <a:ext cx="2633472" cy="246888"/>
           </a:xfrm>
           <a:prstGeom prst="roundRect">
             <a:avLst>
@@ -18763,7 +19093,7 @@
         <p:spPr>
           <a:xfrm>
             <a:off x="8823960" y="2596896"/>
-            <a:ext cx="2633472" cy="219456"/>
+            <a:ext cx="2633472" cy="246888"/>
           </a:xfrm>
           <a:prstGeom prst="rect">
             <a:avLst/>
@@ -18778,7 +19108,7 @@
           <a:p>
             <a:pPr algn="ctr">
               <a:lnSpc>
-                <a:spcPct val="125000"/>
+                <a:spcPct val="100000"/>
               </a:lnSpc>
             </a:pPr>
             <a:r>
@@ -18910,7 +19240,7 @@
               </a:lnSpc>
             </a:pPr>
             <a:r>
-              <a:rPr sz="950" b="1" i="0">
+              <a:rPr sz="850" b="1" i="0">
                 <a:solidFill>
                   <a:srgbClr val="878E99"/>
                 </a:solidFill>
@@ -18990,7 +19320,7 @@
               </a:lnSpc>
             </a:pPr>
             <a:r>
-              <a:rPr sz="2000" b="1" i="0">
+              <a:rPr sz="1400" b="1" i="0">
                 <a:solidFill>
                   <a:srgbClr val="C6532D"/>
                 </a:solidFill>
@@ -19122,7 +19452,7 @@
               </a:lnSpc>
             </a:pPr>
             <a:r>
-              <a:rPr sz="950" b="1" i="0">
+              <a:rPr sz="850" b="1" i="0">
                 <a:solidFill>
                   <a:srgbClr val="316B69"/>
                 </a:solidFill>
@@ -19143,7 +19473,7 @@
         <p:spPr>
           <a:xfrm>
             <a:off x="8823960" y="3712463"/>
-            <a:ext cx="2633472" cy="219456"/>
+            <a:ext cx="2633472" cy="246888"/>
           </a:xfrm>
           <a:prstGeom prst="roundRect">
             <a:avLst>
@@ -19189,7 +19519,7 @@
         <p:spPr>
           <a:xfrm>
             <a:off x="8823960" y="3712463"/>
-            <a:ext cx="2633472" cy="219456"/>
+            <a:ext cx="2633472" cy="246888"/>
           </a:xfrm>
           <a:prstGeom prst="rect">
             <a:avLst/>
@@ -19204,7 +19534,7 @@
           <a:p>
             <a:pPr algn="ctr">
               <a:lnSpc>
-                <a:spcPct val="125000"/>
+                <a:spcPct val="100000"/>
               </a:lnSpc>
             </a:pPr>
             <a:r>
@@ -19334,7 +19664,7 @@
               </a:lnSpc>
             </a:pPr>
             <a:r>
-              <a:rPr sz="1200" b="1" i="0">
+              <a:rPr sz="1050" b="1" i="0">
                 <a:solidFill>
                   <a:srgbClr val="D19830"/>
                 </a:solidFill>
@@ -19422,7 +19752,7 @@
               </a:lnSpc>
             </a:pPr>
             <a:r>
-              <a:rPr sz="1080" b="1" i="0">
+              <a:rPr sz="930" b="1" i="0">
                 <a:solidFill>
                   <a:srgbClr val="F2EFE9"/>
                 </a:solidFill>
@@ -19550,7 +19880,7 @@
               </a:lnSpc>
             </a:pPr>
             <a:r>
-              <a:rPr sz="1080" b="1" i="0">
+              <a:rPr sz="930" b="1" i="0">
                 <a:solidFill>
                   <a:srgbClr val="F2EFE9"/>
                 </a:solidFill>
@@ -19678,7 +20008,7 @@
               </a:lnSpc>
             </a:pPr>
             <a:r>
-              <a:rPr sz="1080" b="1" i="0">
+              <a:rPr sz="930" b="1" i="0">
                 <a:solidFill>
                   <a:srgbClr val="F2EFE9"/>
                 </a:solidFill>
@@ -19718,7 +20048,7 @@
               </a:lnSpc>
             </a:pPr>
             <a:r>
-              <a:rPr sz="950" b="0" i="0">
+              <a:rPr sz="850" b="0" i="0">
                 <a:solidFill>
                   <a:srgbClr val="B2BAC6"/>
                 </a:solidFill>
@@ -19758,14 +20088,134 @@
       <p:grpSpPr/>
       <p:sp>
         <p:nvSpPr>
-          <p:cNvPr id="2" name="Rectangle 1"/>
+          <p:cNvPr id="2" name="TextBox 1"/>
+          <p:cNvSpPr txBox="1"/>
+          <p:nvPr/>
+        </p:nvSpPr>
+        <p:spPr>
+          <a:xfrm>
+            <a:off x="768096" y="329184"/>
+            <a:ext cx="10789920" cy="219760"/>
+          </a:xfrm>
+          <a:prstGeom prst="rect">
+            <a:avLst/>
+          </a:prstGeom>
+          <a:noFill/>
+        </p:spPr>
+        <p:txBody>
+          <a:bodyPr wrap="square" anchor="t" lIns="18288" rIns="18288" tIns="12801" bIns="12801">
+            <a:spAutoFit/>
+          </a:bodyPr>
+          <a:lstStyle/>
+          <a:p>
+            <a:pPr algn="l">
+              <a:lnSpc>
+                <a:spcPct val="125000"/>
+              </a:lnSpc>
+            </a:pPr>
+            <a:r>
+              <a:rPr sz="800" b="1" i="0">
+                <a:solidFill>
+                  <a:srgbClr val="C6532D"/>
+                </a:solidFill>
+                <a:latin typeface="Noto Sans CJK KR"/>
+                <a:ea typeface="Noto Sans CJK KR"/>
+              </a:rPr>
+              <a:t>08  |  DRAFTING &amp; 3-PASS REVISION PROCESS</a:t>
+            </a:r>
+          </a:p>
+        </p:txBody>
+      </p:sp>
+      <p:sp>
+        <p:nvSpPr>
+          <p:cNvPr id="3" name="TextBox 2"/>
+          <p:cNvSpPr txBox="1"/>
+          <p:nvPr/>
+        </p:nvSpPr>
+        <p:spPr>
+          <a:xfrm>
+            <a:off x="768096" y="631240"/>
+            <a:ext cx="10789920" cy="423164"/>
+          </a:xfrm>
+          <a:prstGeom prst="rect">
+            <a:avLst/>
+          </a:prstGeom>
+          <a:noFill/>
+        </p:spPr>
+        <p:txBody>
+          <a:bodyPr wrap="square" anchor="t" lIns="18288" rIns="18288" tIns="12801" bIns="12801">
+            <a:spAutoFit/>
+          </a:bodyPr>
+          <a:lstStyle/>
+          <a:p>
+            <a:pPr algn="l">
+              <a:lnSpc>
+                <a:spcPct val="125000"/>
+              </a:lnSpc>
+            </a:pPr>
+            <a:r>
+              <a:rPr sz="1700" b="1" i="0">
+                <a:solidFill>
+                  <a:srgbClr val="1A212E"/>
+                </a:solidFill>
+                <a:latin typeface="Noto Sans CJK KR"/>
+                <a:ea typeface="Noto Sans CJK KR"/>
+              </a:rPr>
+              <a:t>초고는 뜨거운 가슴으로 거침없이 쓰고, 퇴고는 차가운 머리로 3단계에 걸쳐 조각한다</a:t>
+            </a:r>
+          </a:p>
+        </p:txBody>
+      </p:sp>
+      <p:sp>
+        <p:nvSpPr>
+          <p:cNvPr id="4" name="TextBox 3"/>
+          <p:cNvSpPr txBox="1"/>
+          <p:nvPr/>
+        </p:nvSpPr>
+        <p:spPr>
+          <a:xfrm>
+            <a:off x="768096" y="1136700"/>
+            <a:ext cx="10789920" cy="247497"/>
+          </a:xfrm>
+          <a:prstGeom prst="rect">
+            <a:avLst/>
+          </a:prstGeom>
+          <a:noFill/>
+        </p:spPr>
+        <p:txBody>
+          <a:bodyPr wrap="square" anchor="t" lIns="18288" rIns="18288" tIns="12801" bIns="12801">
+            <a:spAutoFit/>
+          </a:bodyPr>
+          <a:lstStyle/>
+          <a:p>
+            <a:pPr algn="l">
+              <a:lnSpc>
+                <a:spcPct val="125000"/>
+              </a:lnSpc>
+            </a:pPr>
+            <a:r>
+              <a:rPr sz="950" b="0" i="0">
+                <a:solidFill>
+                  <a:srgbClr val="555E6C"/>
+                </a:solidFill>
+                <a:latin typeface="Noto Sans CJK KR"/>
+                <a:ea typeface="Noto Sans CJK KR"/>
+              </a:rPr>
+              <a:t>완벽주의 때문에 첫 장만 무한히 고치는 함정에서 벗어나, 구조·장면·문장의 순서로 해상도를 높여가며 다듬는다</a:t>
+            </a:r>
+          </a:p>
+        </p:txBody>
+      </p:sp>
+      <p:sp>
+        <p:nvSpPr>
+          <p:cNvPr id="5" name="Rectangle 4"/>
           <p:cNvSpPr/>
           <p:nvPr/>
         </p:nvSpPr>
         <p:spPr>
           <a:xfrm>
             <a:off x="594360" y="384048"/>
-            <a:ext cx="73152" cy="713232"/>
+            <a:ext cx="73152" cy="917854"/>
           </a:xfrm>
           <a:prstGeom prst="rect">
             <a:avLst/>
@@ -19802,133 +20252,13 @@
       </p:sp>
       <p:sp>
         <p:nvSpPr>
-          <p:cNvPr id="3" name="TextBox 2"/>
-          <p:cNvSpPr txBox="1"/>
-          <p:nvPr/>
-        </p:nvSpPr>
-        <p:spPr>
-          <a:xfrm>
-            <a:off x="768096" y="329184"/>
-            <a:ext cx="8229600" cy="256032"/>
-          </a:xfrm>
-          <a:prstGeom prst="rect">
-            <a:avLst/>
-          </a:prstGeom>
-          <a:noFill/>
-        </p:spPr>
-        <p:txBody>
-          <a:bodyPr wrap="square" anchor="t" lIns="18288" rIns="18288" tIns="12801" bIns="12801">
-            <a:spAutoFit/>
-          </a:bodyPr>
-          <a:lstStyle/>
-          <a:p>
-            <a:pPr algn="l">
-              <a:lnSpc>
-                <a:spcPct val="125000"/>
-              </a:lnSpc>
-            </a:pPr>
-            <a:r>
-              <a:rPr sz="1050" b="1" i="0">
-                <a:solidFill>
-                  <a:srgbClr val="C6532D"/>
-                </a:solidFill>
-                <a:latin typeface="Noto Sans CJK KR"/>
-                <a:ea typeface="Noto Sans CJK KR"/>
-              </a:rPr>
-              <a:t>08  |  DRAFTING &amp; 3-PASS REVISION PROCESS</a:t>
-            </a:r>
-          </a:p>
-        </p:txBody>
-      </p:sp>
-      <p:sp>
-        <p:nvSpPr>
-          <p:cNvPr id="4" name="TextBox 3"/>
-          <p:cNvSpPr txBox="1"/>
-          <p:nvPr/>
-        </p:nvSpPr>
-        <p:spPr>
-          <a:xfrm>
-            <a:off x="768096" y="548640"/>
-            <a:ext cx="10789920" cy="402336"/>
-          </a:xfrm>
-          <a:prstGeom prst="rect">
-            <a:avLst/>
-          </a:prstGeom>
-          <a:noFill/>
-        </p:spPr>
-        <p:txBody>
-          <a:bodyPr wrap="square" anchor="t" lIns="18288" rIns="18288" tIns="12801" bIns="12801">
-            <a:spAutoFit/>
-          </a:bodyPr>
-          <a:lstStyle/>
-          <a:p>
-            <a:pPr algn="l">
-              <a:lnSpc>
-                <a:spcPct val="125000"/>
-              </a:lnSpc>
-            </a:pPr>
-            <a:r>
-              <a:rPr sz="2150" b="1" i="0">
-                <a:solidFill>
-                  <a:srgbClr val="1A212E"/>
-                </a:solidFill>
-                <a:latin typeface="Noto Sans CJK KR"/>
-                <a:ea typeface="Noto Sans CJK KR"/>
-              </a:rPr>
-              <a:t>초고는 뜨거운 가슴으로 거침없이 쓰고, 퇴고는 차가운 머리로 3단계에 걸쳐 조각한다</a:t>
-            </a:r>
-          </a:p>
-        </p:txBody>
-      </p:sp>
-      <p:sp>
-        <p:nvSpPr>
-          <p:cNvPr id="5" name="TextBox 4"/>
-          <p:cNvSpPr txBox="1"/>
-          <p:nvPr/>
-        </p:nvSpPr>
-        <p:spPr>
-          <a:xfrm>
-            <a:off x="768096" y="923544"/>
-            <a:ext cx="10789920" cy="292608"/>
-          </a:xfrm>
-          <a:prstGeom prst="rect">
-            <a:avLst/>
-          </a:prstGeom>
-          <a:noFill/>
-        </p:spPr>
-        <p:txBody>
-          <a:bodyPr wrap="square" anchor="t" lIns="18288" rIns="18288" tIns="12801" bIns="12801">
-            <a:spAutoFit/>
-          </a:bodyPr>
-          <a:lstStyle/>
-          <a:p>
-            <a:pPr algn="l">
-              <a:lnSpc>
-                <a:spcPct val="125000"/>
-              </a:lnSpc>
-            </a:pPr>
-            <a:r>
-              <a:rPr sz="1200" b="0" i="0">
-                <a:solidFill>
-                  <a:srgbClr val="555E6C"/>
-                </a:solidFill>
-                <a:latin typeface="Noto Sans CJK KR"/>
-                <a:ea typeface="Noto Sans CJK KR"/>
-              </a:rPr>
-              <a:t>완벽주의 때문에 첫 장만 무한히 고치는 함정에서 벗어나, 구조·장면·문장의 순서로 해상도를 높여가며 다듬는다</a:t>
-            </a:r>
-          </a:p>
-        </p:txBody>
-      </p:sp>
-      <p:sp>
-        <p:nvSpPr>
           <p:cNvPr id="6" name="Rectangle 5"/>
           <p:cNvSpPr/>
           <p:nvPr/>
         </p:nvSpPr>
         <p:spPr>
           <a:xfrm>
-            <a:off x="594360" y="1261872"/>
+            <a:off x="594360" y="1457350"/>
             <a:ext cx="11000232" cy="13716"/>
           </a:xfrm>
           <a:prstGeom prst="rect">
@@ -20164,7 +20494,7 @@
               </a:lnSpc>
             </a:pPr>
             <a:r>
-              <a:rPr sz="1350" b="1" i="0">
+              <a:rPr sz="1200" b="1" i="0">
                 <a:solidFill>
                   <a:srgbClr val="C6532D"/>
                 </a:solidFill>
@@ -20204,15 +20534,36 @@
               </a:lnSpc>
             </a:pPr>
             <a:r>
-              <a:rPr sz="1100" b="0" i="0">
+              <a:rPr sz="850" b="0" i="0">
                 <a:solidFill>
                   <a:srgbClr val="1A212E"/>
                 </a:solidFill>
                 <a:latin typeface="Noto Sans CJK KR"/>
                 <a:ea typeface="Noto Sans CJK KR"/>
               </a:rPr>
-              <a:t>“초고를 쓸 때는 내면의 편집자를 방문 밖에 가두어라.”
-백지 위에서는 그 어떤 퇴고도 불가능하다. 문장이 거칠고 설정에 구멍이 나더라도 일단 결말의 마침표까지 달려가 전체 윤곽을 확보하는 것이 최우선이다.</a:t>
+              <a:t>“초고를 쓸 때는 내면의 편집자를 방문 밖에 가두어라.”</a:t>
+            </a:r>
+            <a:br/>
+            <a:r>
+              <a:rPr sz="850" b="0" i="0">
+                <a:solidFill>
+                  <a:srgbClr val="1A212E"/>
+                </a:solidFill>
+                <a:latin typeface="Noto Sans CJK KR"/>
+                <a:ea typeface="Noto Sans CJK KR"/>
+              </a:rPr>
+              <a:t/>
+            </a:r>
+            <a:br/>
+            <a:r>
+              <a:rPr sz="850" b="0" i="0">
+                <a:solidFill>
+                  <a:srgbClr val="1A212E"/>
+                </a:solidFill>
+                <a:latin typeface="Noto Sans CJK KR"/>
+                <a:ea typeface="Noto Sans CJK KR"/>
+              </a:rPr>
+              <a:t>백지 위에서는 그 어떤 퇴고도 불가능하다. 문장이 거칠고 설정에 구멍이 나더라도 일단 결말의 마침표까지 달려가 전체 윤곽을 확보하는 것이 최우선이다.</a:t>
             </a:r>
           </a:p>
         </p:txBody>
@@ -20293,7 +20644,7 @@
               </a:lnSpc>
             </a:pPr>
             <a:r>
-              <a:rPr sz="1150" b="1" i="0">
+              <a:rPr sz="1050" b="1" i="0">
                 <a:solidFill>
                   <a:srgbClr val="1A212E"/>
                 </a:solidFill>
@@ -20592,8 +20943,18 @@
                 <a:latin typeface="Noto Sans CJK KR"/>
                 <a:ea typeface="Noto Sans CJK KR"/>
               </a:rPr>
-              <a:t>• 기획·구조 설계 (20%)  • 초고 집필 (30%)
-• 3단계 퇴고 및 윤문 (50%) — 진짜 소설은 퇴고에서 태어난다.</a:t>
+              <a:t>• 기획·구조 설계 (20%)  • 초고 집필 (30%)</a:t>
+            </a:r>
+            <a:br/>
+            <a:r>
+              <a:rPr sz="980" b="0" i="0">
+                <a:solidFill>
+                  <a:srgbClr val="555E6C"/>
+                </a:solidFill>
+                <a:latin typeface="Noto Sans CJK KR"/>
+                <a:ea typeface="Noto Sans CJK KR"/>
+              </a:rPr>
+              <a:t>• 3단계 퇴고 및 윤문 (50%) — 진짜 소설은 퇴고에서 태어난다.</a:t>
             </a:r>
           </a:p>
         </p:txBody>
@@ -20672,7 +21033,7 @@
               </a:lnSpc>
             </a:pPr>
             <a:r>
-              <a:rPr sz="1150" b="1" i="0">
+              <a:rPr sz="1050" b="1" i="0">
                 <a:solidFill>
                   <a:srgbClr val="D19830"/>
                 </a:solidFill>
@@ -20930,7 +21291,7 @@
               </a:lnSpc>
             </a:pPr>
             <a:r>
-              <a:rPr sz="1400" b="1" i="0">
+              <a:rPr sz="1100" b="1" i="0">
                 <a:solidFill>
                   <a:srgbClr val="1A212E"/>
                 </a:solidFill>
@@ -20950,7 +21311,7 @@
         </p:nvSpPr>
         <p:spPr>
           <a:xfrm>
-            <a:off x="6272784" y="1810512"/>
+            <a:off x="6272784" y="1847088"/>
             <a:ext cx="5120640" cy="219456"/>
           </a:xfrm>
           <a:prstGeom prst="rect">
@@ -20970,7 +21331,7 @@
               </a:lnSpc>
             </a:pPr>
             <a:r>
-              <a:rPr sz="1019" b="1" i="0">
+              <a:rPr sz="869" b="1" i="0">
                 <a:solidFill>
                   <a:srgbClr val="C6532D"/>
                 </a:solidFill>
@@ -21017,9 +21378,29 @@
                 <a:latin typeface="Noto Sans CJK KR"/>
                 <a:ea typeface="Noto Sans CJK KR"/>
               </a:rPr>
-              <a:t>✓ 주인공의 욕망과 행동이 시작부터 클라이맥스까지 일관되게 이어지는가?
-✓ 중반부가 늘어지지 않는가? (기능이 겹치는 장면과 인물을 과감히 통합·삭제)
-✓ 복선이 회수되었으며, 결말이 우연이 아닌 주인공의 선택으로 해결되는가?</a:t>
+              <a:t>✓ 주인공의 욕망과 행동이 시작부터 클라이맥스까지 일관되게 이어지는가?</a:t>
+            </a:r>
+            <a:br/>
+            <a:r>
+              <a:rPr sz="1030" b="0" i="0">
+                <a:solidFill>
+                  <a:srgbClr val="555E6C"/>
+                </a:solidFill>
+                <a:latin typeface="Noto Sans CJK KR"/>
+                <a:ea typeface="Noto Sans CJK KR"/>
+              </a:rPr>
+              <a:t>✓ 중반부가 늘어지지 않는가? (기능이 겹치는 장면과 인물을 과감히 통합·삭제)</a:t>
+            </a:r>
+            <a:br/>
+            <a:r>
+              <a:rPr sz="1030" b="0" i="0">
+                <a:solidFill>
+                  <a:srgbClr val="555E6C"/>
+                </a:solidFill>
+                <a:latin typeface="Noto Sans CJK KR"/>
+                <a:ea typeface="Noto Sans CJK KR"/>
+              </a:rPr>
+              <a:t>✓ 복선이 회수되었으며, 결말이 우연이 아닌 주인공의 선택으로 해결되는가?</a:t>
             </a:r>
           </a:p>
         </p:txBody>
@@ -21230,7 +21611,7 @@
               </a:lnSpc>
             </a:pPr>
             <a:r>
-              <a:rPr sz="1400" b="1" i="0">
+              <a:rPr sz="1100" b="1" i="0">
                 <a:solidFill>
                   <a:srgbClr val="1A212E"/>
                 </a:solidFill>
@@ -21250,7 +21631,7 @@
         </p:nvSpPr>
         <p:spPr>
           <a:xfrm>
-            <a:off x="6272784" y="3474720"/>
+            <a:off x="6272784" y="3511296"/>
             <a:ext cx="5120640" cy="219456"/>
           </a:xfrm>
           <a:prstGeom prst="rect">
@@ -21270,7 +21651,7 @@
               </a:lnSpc>
             </a:pPr>
             <a:r>
-              <a:rPr sz="1019" b="1" i="0">
+              <a:rPr sz="869" b="1" i="0">
                 <a:solidFill>
                   <a:srgbClr val="316B69"/>
                 </a:solidFill>
@@ -21317,9 +21698,29 @@
                 <a:latin typeface="Noto Sans CJK KR"/>
                 <a:ea typeface="Noto Sans CJK KR"/>
               </a:rPr>
-              <a:t>✓ 각 장면의 첫 문장이 흥미롭고 마지막 문장이 다음 장면을 궁금하게 만드는가?
-✓ 한 장면 안에서 시점(POV)이 흔들리거나 설명(Tell)이 과도한 구간은 없는가?
-✓ 긴박한 장면에서는 단문으로 속도를 높이고, 정서적 장면에서는 호흡을 늦추었는가?</a:t>
+              <a:t>✓ 각 장면의 첫 문장이 흥미롭고 마지막 문장이 다음 장면을 궁금하게 만드는가?</a:t>
+            </a:r>
+            <a:br/>
+            <a:r>
+              <a:rPr sz="1030" b="0" i="0">
+                <a:solidFill>
+                  <a:srgbClr val="555E6C"/>
+                </a:solidFill>
+                <a:latin typeface="Noto Sans CJK KR"/>
+                <a:ea typeface="Noto Sans CJK KR"/>
+              </a:rPr>
+              <a:t>✓ 한 장면 안에서 시점(POV)이 흔들리거나 설명(Tell)이 과도한 구간은 없는가?</a:t>
+            </a:r>
+            <a:br/>
+            <a:r>
+              <a:rPr sz="1030" b="0" i="0">
+                <a:solidFill>
+                  <a:srgbClr val="555E6C"/>
+                </a:solidFill>
+                <a:latin typeface="Noto Sans CJK KR"/>
+                <a:ea typeface="Noto Sans CJK KR"/>
+              </a:rPr>
+              <a:t>✓ 긴박한 장면에서는 단문으로 속도를 높이고, 정서적 장면에서는 호흡을 늦추었는가?</a:t>
             </a:r>
           </a:p>
         </p:txBody>
@@ -21530,7 +21931,7 @@
               </a:lnSpc>
             </a:pPr>
             <a:r>
-              <a:rPr sz="1400" b="1" i="0">
+              <a:rPr sz="1100" b="1" i="0">
                 <a:solidFill>
                   <a:srgbClr val="1A212E"/>
                 </a:solidFill>
@@ -21550,7 +21951,7 @@
         </p:nvSpPr>
         <p:spPr>
           <a:xfrm>
-            <a:off x="6272784" y="5138928"/>
+            <a:off x="6272784" y="5175504"/>
             <a:ext cx="5120640" cy="219456"/>
           </a:xfrm>
           <a:prstGeom prst="rect">
@@ -21570,7 +21971,7 @@
               </a:lnSpc>
             </a:pPr>
             <a:r>
-              <a:rPr sz="1019" b="1" i="0">
+              <a:rPr sz="869" b="1" i="0">
                 <a:solidFill>
                   <a:srgbClr val="D19830"/>
                 </a:solidFill>
@@ -21617,9 +22018,29 @@
                 <a:latin typeface="Noto Sans CJK KR"/>
                 <a:ea typeface="Noto Sans CJK KR"/>
               </a:rPr>
-              <a:t>✓ 상투적 부사(‘매우, 정말, 문득, 갑자기’)와 번역투(‘~에 다름 아니다, ~로부터’) 제거
-✓ 한 문장에 중복된 주어(‘그는 ~ 그의 ~’)와 불필요한 피동형(‘~되어졌다’) 교정
-✓ 육성으로 낭독(Read Aloud)했을 때 숨이 차거나 어색하게 걸리는 대사 수정</a:t>
+              <a:t>✓ 상투적 부사(‘매우, 정말, 문득, 갑자기’)와 번역투(‘~에 다름 아니다, ~로부터’) 제거</a:t>
+            </a:r>
+            <a:br/>
+            <a:r>
+              <a:rPr sz="1030" b="0" i="0">
+                <a:solidFill>
+                  <a:srgbClr val="555E6C"/>
+                </a:solidFill>
+                <a:latin typeface="Noto Sans CJK KR"/>
+                <a:ea typeface="Noto Sans CJK KR"/>
+              </a:rPr>
+              <a:t>✓ 한 문장에 중복된 주어(‘그는 ~ 그의 ~’)와 불필요한 피동형(‘~되어졌다’) 교정</a:t>
+            </a:r>
+            <a:br/>
+            <a:r>
+              <a:rPr sz="1030" b="0" i="0">
+                <a:solidFill>
+                  <a:srgbClr val="555E6C"/>
+                </a:solidFill>
+                <a:latin typeface="Noto Sans CJK KR"/>
+                <a:ea typeface="Noto Sans CJK KR"/>
+              </a:rPr>
+              <a:t>✓ 육성으로 낭독(Read Aloud)했을 때 숨이 차거나 어색하게 걸리는 대사 수정</a:t>
             </a:r>
           </a:p>
         </p:txBody>

</xml_diff>